<commit_message>
Rebuild Data Cleaning slide as a fact-checked 4-card layout
A review caught two inaccuracies in the original slide: the PAY_*
grouping claim overstated what common.py actually does (the raw
columns are untouched; -2/-1/0 collapse only happens inside
specific aggregate lateness features, and two features deliberately
preserve the original codes), and the EDUCATION "other" fairness
cost was hedged as "alleged" when it's a confirmed, measured
finding in the fairness audit. Rewrite cards 01/02 to match
models/common.py and REPORT.md exactly, keep 03 unchanged, and add
a 04 card for cleaning decisions that were missing from the slide
entirely (no missing values, no outlier removal, no resampling,
client_id dropped). Applied to both the Figma deck and the pptx.
</commit_message>
<xml_diff>
--- a/presentation/finalist-presentation.pptx
+++ b/presentation/finalist-presentation.pptx
@@ -6153,14 +6153,140 @@
       </p:sp>
       <p:sp>
         <p:nvSpPr>
-          <p:cNvPr id="5" name="TextBox 4"/>
-          <p:cNvSpPr txBox="1"/>
-          <p:nvPr/>
-        </p:nvSpPr>
-        <p:spPr>
-          <a:xfrm>
-            <a:off x="640080" y="1737360"/>
-            <a:ext cx="5486400" cy="3291840"/>
+          <p:cNvPr id="5" name="Rounded Rectangle 4"/>
+          <p:cNvSpPr/>
+          <p:nvPr/>
+        </p:nvSpPr>
+        <p:spPr>
+          <a:xfrm>
+            <a:off x="640080" y="1600200"/>
+            <a:ext cx="5212080" cy="2148840"/>
+          </a:xfrm>
+          <a:prstGeom prst="roundRect">
+            <a:avLst>
+              <a:gd name="adj" fmla="val 4000"/>
+            </a:avLst>
+          </a:prstGeom>
+          <a:solidFill>
+            <a:srgbClr val="FFFFFF"/>
+          </a:solidFill>
+          <a:ln w="12700">
+            <a:solidFill>
+              <a:srgbClr val="D2D2D7"/>
+            </a:solidFill>
+          </a:ln>
+          <a:effectLst/>
+        </p:spPr>
+        <p:style>
+          <a:lnRef idx="1">
+            <a:schemeClr val="accent1"/>
+          </a:lnRef>
+          <a:fillRef idx="3">
+            <a:schemeClr val="accent1"/>
+          </a:fillRef>
+          <a:effectRef idx="2">
+            <a:schemeClr val="accent1"/>
+          </a:effectRef>
+          <a:fontRef idx="minor">
+            <a:schemeClr val="lt1"/>
+          </a:fontRef>
+        </p:style>
+        <p:txBody>
+          <a:bodyPr rtlCol="0" anchor="ctr"/>
+          <a:lstStyle/>
+          <a:p>
+            <a:pPr algn="ctr"/>
+          </a:p>
+        </p:txBody>
+      </p:sp>
+      <p:sp>
+        <p:nvSpPr>
+          <p:cNvPr id="6" name="TextBox 5"/>
+          <p:cNvSpPr txBox="1"/>
+          <p:nvPr/>
+        </p:nvSpPr>
+        <p:spPr>
+          <a:xfrm>
+            <a:off x="841248" y="1728216"/>
+            <a:ext cx="914400" cy="457200"/>
+          </a:xfrm>
+          <a:prstGeom prst="rect">
+            <a:avLst/>
+          </a:prstGeom>
+          <a:noFill/>
+        </p:spPr>
+        <p:txBody>
+          <a:bodyPr wrap="square" anchor="t" lIns="0" rIns="0" tIns="0" bIns="0">
+            <a:spAutoFit/>
+          </a:bodyPr>
+          <a:lstStyle/>
+          <a:p>
+            <a:pPr algn="l">
+              <a:lnSpc>
+                <a:spcPct val="100000"/>
+              </a:lnSpc>
+            </a:pPr>
+            <a:r>
+              <a:rPr sz="3000" b="1" i="0">
+                <a:solidFill>
+                  <a:srgbClr val="D2D2D7"/>
+                </a:solidFill>
+                <a:latin typeface="Helvetica Neue"/>
+              </a:rPr>
+              <a:t>01</a:t>
+            </a:r>
+          </a:p>
+        </p:txBody>
+      </p:sp>
+      <p:sp>
+        <p:nvSpPr>
+          <p:cNvPr id="7" name="TextBox 6"/>
+          <p:cNvSpPr txBox="1"/>
+          <p:nvPr/>
+        </p:nvSpPr>
+        <p:spPr>
+          <a:xfrm>
+            <a:off x="841248" y="2167128"/>
+            <a:ext cx="4809744" cy="365760"/>
+          </a:xfrm>
+          <a:prstGeom prst="rect">
+            <a:avLst/>
+          </a:prstGeom>
+          <a:noFill/>
+        </p:spPr>
+        <p:txBody>
+          <a:bodyPr wrap="square" anchor="t" lIns="0" rIns="0" tIns="0" bIns="0">
+            <a:spAutoFit/>
+          </a:bodyPr>
+          <a:lstStyle/>
+          <a:p>
+            <a:pPr algn="l">
+              <a:lnSpc>
+                <a:spcPct val="100000"/>
+              </a:lnSpc>
+            </a:pPr>
+            <a:r>
+              <a:rPr sz="1700" b="1" i="0">
+                <a:solidFill>
+                  <a:srgbClr val="1D1D1F"/>
+                </a:solidFill>
+                <a:latin typeface="Helvetica Neue"/>
+              </a:rPr>
+              <a:t>Repayment Status</a:t>
+            </a:r>
+          </a:p>
+        </p:txBody>
+      </p:sp>
+      <p:sp>
+        <p:nvSpPr>
+          <p:cNvPr id="8" name="TextBox 7"/>
+          <p:cNvSpPr txBox="1"/>
+          <p:nvPr/>
+        </p:nvSpPr>
+        <p:spPr>
+          <a:xfrm>
+            <a:off x="841248" y="2560320"/>
+            <a:ext cx="4809744" cy="1051560"/>
           </a:xfrm>
           <a:prstGeom prst="rect">
             <a:avLst/>
@@ -6178,17 +6304,17 @@
                 <a:spcPct val="108000"/>
               </a:lnSpc>
               <a:spcAft>
-                <a:spcPts val="900"/>
+                <a:spcPts val="700"/>
               </a:spcAft>
             </a:pPr>
             <a:r>
-              <a:rPr sz="1650">
+              <a:rPr sz="1150">
                 <a:solidFill>
                   <a:srgbClr val="1D1D1F"/>
                 </a:solidFill>
                 <a:latin typeface="Helvetica Neue"/>
               </a:rPr>
-              <a:t>-  No missing values and no malformed rows in the raw data.</a:t>
+              <a:t>-  PAY_0, PAY_2 through PAY_6 show months behind on payment.</a:t>
             </a:r>
           </a:p>
           <a:p>
@@ -6197,17 +6323,17 @@
                 <a:spcPct val="108000"/>
               </a:lnSpc>
               <a:spcAft>
-                <a:spcPts val="900"/>
+                <a:spcPts val="700"/>
               </a:spcAft>
             </a:pPr>
             <a:r>
-              <a:rPr sz="1650">
+              <a:rPr sz="1150">
                 <a:solidFill>
                   <a:srgbClr val="1D1D1F"/>
                 </a:solidFill>
                 <a:latin typeface="Helvetica Neue"/>
               </a:rPr>
-              <a:t>-  EDUCATION codes 0, 5, 6 grouped into "other", 290 rows.</a:t>
+              <a:t>-  -2 = no balance, -1 = paid in full, 0 = paid minimum amount.</a:t>
             </a:r>
           </a:p>
           <a:p>
@@ -6216,17 +6342,17 @@
                 <a:spcPct val="108000"/>
               </a:lnSpc>
               <a:spcAft>
-                <a:spcPts val="900"/>
+                <a:spcPts val="700"/>
               </a:spcAft>
             </a:pPr>
             <a:r>
-              <a:rPr sz="1650">
+              <a:rPr sz="1150">
                 <a:solidFill>
                   <a:srgbClr val="1D1D1F"/>
                 </a:solidFill>
                 <a:latin typeface="Helvetica Neue"/>
               </a:rPr>
-              <a:t>-  MARRIAGE code 0 grouped into "other", 42 rows.</a:t>
+              <a:t>-  Raw values stay untouched in the cleaned dataset, no grouping here.</a:t>
             </a:r>
           </a:p>
           <a:p>
@@ -6235,17 +6361,17 @@
                 <a:spcPct val="108000"/>
               </a:lnSpc>
               <a:spcAft>
-                <a:spcPts val="900"/>
+                <a:spcPts val="700"/>
               </a:spcAft>
             </a:pPr>
             <a:r>
-              <a:rPr sz="1650">
+              <a:rPr sz="1150">
                 <a:solidFill>
                   <a:srgbClr val="1D1D1F"/>
                 </a:solidFill>
                 <a:latin typeface="Helvetica Neue"/>
               </a:rPr>
-              <a:t>-  PAY status −1 and −2 kept as-is: paid-in-full and inactive account, not missing data.</a:t>
+              <a:t>-  Aggregate lateness features (pay_max, n_late, trend_pay) clip -2/-1/0 to 0 only.</a:t>
             </a:r>
           </a:p>
           <a:p>
@@ -6254,74 +6380,304 @@
                 <a:spcPct val="108000"/>
               </a:lnSpc>
               <a:spcAft>
-                <a:spcPts val="900"/>
+                <a:spcPts val="700"/>
               </a:spcAft>
             </a:pPr>
             <a:r>
-              <a:rPr sz="1650">
+              <a:rPr sz="1150">
                 <a:solidFill>
                   <a:srgbClr val="1D1D1F"/>
                 </a:solidFill>
                 <a:latin typeface="Helvetica Neue"/>
               </a:rPr>
-              <a:t>-  No outlier removal, large balances/payments can be genuine risk signal.</a:t>
-            </a:r>
-          </a:p>
+              <a:t>-  ever_paid_full and never_used deliberately keep the original codes.</a:t>
+            </a:r>
+          </a:p>
+        </p:txBody>
+      </p:sp>
+      <p:sp>
+        <p:nvSpPr>
+          <p:cNvPr id="9" name="Rounded Rectangle 8"/>
+          <p:cNvSpPr/>
+          <p:nvPr/>
+        </p:nvSpPr>
+        <p:spPr>
+          <a:xfrm>
+            <a:off x="6126480" y="1600200"/>
+            <a:ext cx="5212080" cy="2148840"/>
+          </a:xfrm>
+          <a:prstGeom prst="roundRect">
+            <a:avLst>
+              <a:gd name="adj" fmla="val 4000"/>
+            </a:avLst>
+          </a:prstGeom>
+          <a:solidFill>
+            <a:srgbClr val="FFFFFF"/>
+          </a:solidFill>
+          <a:ln w="12700">
+            <a:solidFill>
+              <a:srgbClr val="D2D2D7"/>
+            </a:solidFill>
+          </a:ln>
+          <a:effectLst/>
+        </p:spPr>
+        <p:style>
+          <a:lnRef idx="1">
+            <a:schemeClr val="accent1"/>
+          </a:lnRef>
+          <a:fillRef idx="3">
+            <a:schemeClr val="accent1"/>
+          </a:fillRef>
+          <a:effectRef idx="2">
+            <a:schemeClr val="accent1"/>
+          </a:effectRef>
+          <a:fontRef idx="minor">
+            <a:schemeClr val="lt1"/>
+          </a:fontRef>
+        </p:style>
+        <p:txBody>
+          <a:bodyPr rtlCol="0" anchor="ctr"/>
+          <a:lstStyle/>
+          <a:p>
+            <a:pPr algn="ctr"/>
+          </a:p>
+        </p:txBody>
+      </p:sp>
+      <p:sp>
+        <p:nvSpPr>
+          <p:cNvPr id="10" name="TextBox 9"/>
+          <p:cNvSpPr txBox="1"/>
+          <p:nvPr/>
+        </p:nvSpPr>
+        <p:spPr>
+          <a:xfrm>
+            <a:off x="6327648" y="1728216"/>
+            <a:ext cx="914400" cy="457200"/>
+          </a:xfrm>
+          <a:prstGeom prst="rect">
+            <a:avLst/>
+          </a:prstGeom>
+          <a:noFill/>
+        </p:spPr>
+        <p:txBody>
+          <a:bodyPr wrap="square" anchor="t" lIns="0" rIns="0" tIns="0" bIns="0">
+            <a:spAutoFit/>
+          </a:bodyPr>
+          <a:lstStyle/>
+          <a:p>
+            <a:pPr algn="l">
+              <a:lnSpc>
+                <a:spcPct val="100000"/>
+              </a:lnSpc>
+            </a:pPr>
+            <a:r>
+              <a:rPr sz="3000" b="1" i="0">
+                <a:solidFill>
+                  <a:srgbClr val="D2D2D7"/>
+                </a:solidFill>
+                <a:latin typeface="Helvetica Neue"/>
+              </a:rPr>
+              <a:t>02</a:t>
+            </a:r>
+          </a:p>
+        </p:txBody>
+      </p:sp>
+      <p:sp>
+        <p:nvSpPr>
+          <p:cNvPr id="11" name="TextBox 10"/>
+          <p:cNvSpPr txBox="1"/>
+          <p:nvPr/>
+        </p:nvSpPr>
+        <p:spPr>
+          <a:xfrm>
+            <a:off x="6327648" y="2167128"/>
+            <a:ext cx="4809744" cy="365760"/>
+          </a:xfrm>
+          <a:prstGeom prst="rect">
+            <a:avLst/>
+          </a:prstGeom>
+          <a:noFill/>
+        </p:spPr>
+        <p:txBody>
+          <a:bodyPr wrap="square" anchor="t" lIns="0" rIns="0" tIns="0" bIns="0">
+            <a:spAutoFit/>
+          </a:bodyPr>
+          <a:lstStyle/>
+          <a:p>
+            <a:pPr algn="l">
+              <a:lnSpc>
+                <a:spcPct val="100000"/>
+              </a:lnSpc>
+            </a:pPr>
+            <a:r>
+              <a:rPr sz="1700" b="1" i="0">
+                <a:solidFill>
+                  <a:srgbClr val="CB382D"/>
+                </a:solidFill>
+                <a:latin typeface="Helvetica Neue"/>
+              </a:rPr>
+              <a:t>Education</a:t>
+            </a:r>
+          </a:p>
+        </p:txBody>
+      </p:sp>
+      <p:sp>
+        <p:nvSpPr>
+          <p:cNvPr id="12" name="TextBox 11"/>
+          <p:cNvSpPr txBox="1"/>
+          <p:nvPr/>
+        </p:nvSpPr>
+        <p:spPr>
+          <a:xfrm>
+            <a:off x="6327648" y="2560320"/>
+            <a:ext cx="4809744" cy="1051560"/>
+          </a:xfrm>
+          <a:prstGeom prst="rect">
+            <a:avLst/>
+          </a:prstGeom>
+          <a:noFill/>
+        </p:spPr>
+        <p:txBody>
+          <a:bodyPr wrap="square" lIns="0" rIns="0" tIns="0" bIns="0">
+            <a:spAutoFit/>
+          </a:bodyPr>
+          <a:lstStyle/>
           <a:p>
             <a:pPr>
               <a:lnSpc>
                 <a:spcPct val="108000"/>
               </a:lnSpc>
               <a:spcAft>
-                <a:spcPts val="900"/>
+                <a:spcPts val="700"/>
               </a:spcAft>
             </a:pPr>
             <a:r>
-              <a:rPr sz="1650">
+              <a:rPr sz="1150">
                 <a:solidFill>
                   <a:srgbClr val="1D1D1F"/>
                 </a:solidFill>
                 <a:latin typeface="Helvetica Neue"/>
               </a:rPr>
-              <a:t>-  No resampling or class weighting, preserves the true 22.12% base rate for calibration.</a:t>
-            </a:r>
-          </a:p>
-        </p:txBody>
-      </p:sp>
-      <p:pic>
-        <p:nvPicPr>
-          <p:cNvPr id="6" name="Picture 5" descr="cleaning_flow.png"/>
-          <p:cNvPicPr>
-            <a:picLocks noChangeAspect="1"/>
-          </p:cNvPicPr>
-          <p:nvPr/>
-        </p:nvPicPr>
-        <p:blipFill>
-          <a:blip r:embed="rId2"/>
-          <a:stretch>
-            <a:fillRect/>
-          </a:stretch>
-        </p:blipFill>
-        <p:spPr>
-          <a:xfrm>
-            <a:off x="6858000" y="2180844"/>
-            <a:ext cx="4709160" cy="941832"/>
-          </a:xfrm>
-          <a:prstGeom prst="rect">
-            <a:avLst/>
-          </a:prstGeom>
-        </p:spPr>
-      </p:pic>
-      <p:sp>
-        <p:nvSpPr>
-          <p:cNvPr id="7" name="TextBox 6"/>
-          <p:cNvSpPr txBox="1"/>
-          <p:nvPr/>
-        </p:nvSpPr>
-        <p:spPr>
-          <a:xfrm>
-            <a:off x="640080" y="5989320"/>
-            <a:ext cx="10881360" cy="548640"/>
+              <a:t>-  1 = graduate school, 2 = university, 3 = high school, 4 = other (official codes).</a:t>
+            </a:r>
+          </a:p>
+          <a:p>
+            <a:pPr>
+              <a:lnSpc>
+                <a:spcPct val="108000"/>
+              </a:lnSpc>
+              <a:spcAft>
+                <a:spcPts val="700"/>
+              </a:spcAft>
+            </a:pPr>
+            <a:r>
+              <a:rPr sz="1150">
+                <a:solidFill>
+                  <a:srgbClr val="1D1D1F"/>
+                </a:solidFill>
+                <a:latin typeface="Helvetica Neue"/>
+              </a:rPr>
+              <a:t>-  Undocumented codes 0, 5, 6 folded into "other" (4), 290 rows.</a:t>
+            </a:r>
+          </a:p>
+          <a:p>
+            <a:pPr>
+              <a:lnSpc>
+                <a:spcPct val="108000"/>
+              </a:lnSpc>
+              <a:spcAft>
+                <a:spcPts val="700"/>
+              </a:spcAft>
+            </a:pPr>
+            <a:r>
+              <a:rPr sz="1150">
+                <a:solidFill>
+                  <a:srgbClr val="1D1D1F"/>
+                </a:solidFill>
+                <a:latin typeface="Helvetica Neue"/>
+              </a:rPr>
+              <a:t>-  Confirmed cost: "other" over-predicted about 61%, AUC 0.645 vs about 0.79 elsewhere.</a:t>
+            </a:r>
+          </a:p>
+          <a:p>
+            <a:pPr>
+              <a:lnSpc>
+                <a:spcPct val="108000"/>
+              </a:lnSpc>
+              <a:spcAft>
+                <a:spcPts val="700"/>
+              </a:spcAft>
+            </a:pPr>
+            <a:r>
+              <a:rPr sz="1150">
+                <a:solidFill>
+                  <a:srgbClr val="1D1D1F"/>
+                </a:solidFill>
+                <a:latin typeface="Helvetica Neue"/>
+              </a:rPr>
+              <a:t>-  The only subgroup where the model underperforms its own base rate.</a:t>
+            </a:r>
+          </a:p>
+        </p:txBody>
+      </p:sp>
+      <p:sp>
+        <p:nvSpPr>
+          <p:cNvPr id="13" name="Rounded Rectangle 12"/>
+          <p:cNvSpPr/>
+          <p:nvPr/>
+        </p:nvSpPr>
+        <p:spPr>
+          <a:xfrm>
+            <a:off x="640080" y="3977640"/>
+            <a:ext cx="5212080" cy="2148840"/>
+          </a:xfrm>
+          <a:prstGeom prst="roundRect">
+            <a:avLst>
+              <a:gd name="adj" fmla="val 4000"/>
+            </a:avLst>
+          </a:prstGeom>
+          <a:solidFill>
+            <a:srgbClr val="FFFFFF"/>
+          </a:solidFill>
+          <a:ln w="12700">
+            <a:solidFill>
+              <a:srgbClr val="D2D2D7"/>
+            </a:solidFill>
+          </a:ln>
+          <a:effectLst/>
+        </p:spPr>
+        <p:style>
+          <a:lnRef idx="1">
+            <a:schemeClr val="accent1"/>
+          </a:lnRef>
+          <a:fillRef idx="3">
+            <a:schemeClr val="accent1"/>
+          </a:fillRef>
+          <a:effectRef idx="2">
+            <a:schemeClr val="accent1"/>
+          </a:effectRef>
+          <a:fontRef idx="minor">
+            <a:schemeClr val="lt1"/>
+          </a:fontRef>
+        </p:style>
+        <p:txBody>
+          <a:bodyPr rtlCol="0" anchor="ctr"/>
+          <a:lstStyle/>
+          <a:p>
+            <a:pPr algn="ctr"/>
+          </a:p>
+        </p:txBody>
+      </p:sp>
+      <p:sp>
+        <p:nvSpPr>
+          <p:cNvPr id="14" name="TextBox 13"/>
+          <p:cNvSpPr txBox="1"/>
+          <p:nvPr/>
+        </p:nvSpPr>
+        <p:spPr>
+          <a:xfrm>
+            <a:off x="841248" y="4105656"/>
+            <a:ext cx="914400" cy="457200"/>
           </a:xfrm>
           <a:prstGeom prst="rect">
             <a:avLst/>
@@ -6340,20 +6696,364 @@
               </a:lnSpc>
             </a:pPr>
             <a:r>
-              <a:rPr sz="1500" b="0" i="1">
-                <a:solidFill>
-                  <a:srgbClr val="6E6E73"/>
-                </a:solidFill>
-                <a:latin typeface="Helvetica Neue"/>
-              </a:rPr>
-              <a:t>Preprocessing preserved meaningful financial states instead of applying generic cleaning steps.</a:t>
-            </a:r>
-          </a:p>
-        </p:txBody>
-      </p:sp>
-      <p:sp>
-        <p:nvSpPr>
-          <p:cNvPr id="8" name="TextBox 7"/>
+              <a:rPr sz="3000" b="1" i="0">
+                <a:solidFill>
+                  <a:srgbClr val="D2D2D7"/>
+                </a:solidFill>
+                <a:latin typeface="Helvetica Neue"/>
+              </a:rPr>
+              <a:t>03</a:t>
+            </a:r>
+          </a:p>
+        </p:txBody>
+      </p:sp>
+      <p:sp>
+        <p:nvSpPr>
+          <p:cNvPr id="15" name="TextBox 14"/>
+          <p:cNvSpPr txBox="1"/>
+          <p:nvPr/>
+        </p:nvSpPr>
+        <p:spPr>
+          <a:xfrm>
+            <a:off x="841248" y="4544568"/>
+            <a:ext cx="4809744" cy="365760"/>
+          </a:xfrm>
+          <a:prstGeom prst="rect">
+            <a:avLst/>
+          </a:prstGeom>
+          <a:noFill/>
+        </p:spPr>
+        <p:txBody>
+          <a:bodyPr wrap="square" anchor="t" lIns="0" rIns="0" tIns="0" bIns="0">
+            <a:spAutoFit/>
+          </a:bodyPr>
+          <a:lstStyle/>
+          <a:p>
+            <a:pPr algn="l">
+              <a:lnSpc>
+                <a:spcPct val="100000"/>
+              </a:lnSpc>
+            </a:pPr>
+            <a:r>
+              <a:rPr sz="1700" b="1" i="0">
+                <a:solidFill>
+                  <a:srgbClr val="1D1D1F"/>
+                </a:solidFill>
+                <a:latin typeface="Helvetica Neue"/>
+              </a:rPr>
+              <a:t>Marriage</a:t>
+            </a:r>
+          </a:p>
+        </p:txBody>
+      </p:sp>
+      <p:sp>
+        <p:nvSpPr>
+          <p:cNvPr id="16" name="TextBox 15"/>
+          <p:cNvSpPr txBox="1"/>
+          <p:nvPr/>
+        </p:nvSpPr>
+        <p:spPr>
+          <a:xfrm>
+            <a:off x="841248" y="4937760"/>
+            <a:ext cx="4809744" cy="1051560"/>
+          </a:xfrm>
+          <a:prstGeom prst="rect">
+            <a:avLst/>
+          </a:prstGeom>
+          <a:noFill/>
+        </p:spPr>
+        <p:txBody>
+          <a:bodyPr wrap="square" lIns="0" rIns="0" tIns="0" bIns="0">
+            <a:spAutoFit/>
+          </a:bodyPr>
+          <a:lstStyle/>
+          <a:p>
+            <a:pPr>
+              <a:lnSpc>
+                <a:spcPct val="108000"/>
+              </a:lnSpc>
+              <a:spcAft>
+                <a:spcPts val="700"/>
+              </a:spcAft>
+            </a:pPr>
+            <a:r>
+              <a:rPr sz="1150">
+                <a:solidFill>
+                  <a:srgbClr val="1D1D1F"/>
+                </a:solidFill>
+                <a:latin typeface="Helvetica Neue"/>
+              </a:rPr>
+              <a:t>-  1 = married, 2 = single, 3 = other (official codes).</a:t>
+            </a:r>
+          </a:p>
+          <a:p>
+            <a:pPr>
+              <a:lnSpc>
+                <a:spcPct val="108000"/>
+              </a:lnSpc>
+              <a:spcAft>
+                <a:spcPts val="700"/>
+              </a:spcAft>
+            </a:pPr>
+            <a:r>
+              <a:rPr sz="1150">
+                <a:solidFill>
+                  <a:srgbClr val="1D1D1F"/>
+                </a:solidFill>
+                <a:latin typeface="Helvetica Neue"/>
+              </a:rPr>
+              <a:t>-  Undocumented code 0 folded into "other" (3), 42 rows.</a:t>
+            </a:r>
+          </a:p>
+          <a:p>
+            <a:pPr>
+              <a:lnSpc>
+                <a:spcPct val="108000"/>
+              </a:lnSpc>
+              <a:spcAft>
+                <a:spcPts val="700"/>
+              </a:spcAft>
+            </a:pPr>
+            <a:r>
+              <a:rPr sz="1150">
+                <a:solidFill>
+                  <a:srgbClr val="1D1D1F"/>
+                </a:solidFill>
+                <a:latin typeface="Helvetica Neue"/>
+              </a:rPr>
+              <a:t>-  No confirmed fairness or accuracy issue for this group.</a:t>
+            </a:r>
+          </a:p>
+        </p:txBody>
+      </p:sp>
+      <p:sp>
+        <p:nvSpPr>
+          <p:cNvPr id="17" name="Rounded Rectangle 16"/>
+          <p:cNvSpPr/>
+          <p:nvPr/>
+        </p:nvSpPr>
+        <p:spPr>
+          <a:xfrm>
+            <a:off x="6126480" y="3977640"/>
+            <a:ext cx="5212080" cy="2148840"/>
+          </a:xfrm>
+          <a:prstGeom prst="roundRect">
+            <a:avLst>
+              <a:gd name="adj" fmla="val 4000"/>
+            </a:avLst>
+          </a:prstGeom>
+          <a:solidFill>
+            <a:srgbClr val="FFFFFF"/>
+          </a:solidFill>
+          <a:ln w="12700">
+            <a:solidFill>
+              <a:srgbClr val="D2D2D7"/>
+            </a:solidFill>
+          </a:ln>
+          <a:effectLst/>
+        </p:spPr>
+        <p:style>
+          <a:lnRef idx="1">
+            <a:schemeClr val="accent1"/>
+          </a:lnRef>
+          <a:fillRef idx="3">
+            <a:schemeClr val="accent1"/>
+          </a:fillRef>
+          <a:effectRef idx="2">
+            <a:schemeClr val="accent1"/>
+          </a:effectRef>
+          <a:fontRef idx="minor">
+            <a:schemeClr val="lt1"/>
+          </a:fontRef>
+        </p:style>
+        <p:txBody>
+          <a:bodyPr rtlCol="0" anchor="ctr"/>
+          <a:lstStyle/>
+          <a:p>
+            <a:pPr algn="ctr"/>
+          </a:p>
+        </p:txBody>
+      </p:sp>
+      <p:sp>
+        <p:nvSpPr>
+          <p:cNvPr id="18" name="TextBox 17"/>
+          <p:cNvSpPr txBox="1"/>
+          <p:nvPr/>
+        </p:nvSpPr>
+        <p:spPr>
+          <a:xfrm>
+            <a:off x="6327648" y="4105656"/>
+            <a:ext cx="914400" cy="457200"/>
+          </a:xfrm>
+          <a:prstGeom prst="rect">
+            <a:avLst/>
+          </a:prstGeom>
+          <a:noFill/>
+        </p:spPr>
+        <p:txBody>
+          <a:bodyPr wrap="square" anchor="t" lIns="0" rIns="0" tIns="0" bIns="0">
+            <a:spAutoFit/>
+          </a:bodyPr>
+          <a:lstStyle/>
+          <a:p>
+            <a:pPr algn="l">
+              <a:lnSpc>
+                <a:spcPct val="100000"/>
+              </a:lnSpc>
+            </a:pPr>
+            <a:r>
+              <a:rPr sz="3000" b="1" i="0">
+                <a:solidFill>
+                  <a:srgbClr val="D2D2D7"/>
+                </a:solidFill>
+                <a:latin typeface="Helvetica Neue"/>
+              </a:rPr>
+              <a:t>04</a:t>
+            </a:r>
+          </a:p>
+        </p:txBody>
+      </p:sp>
+      <p:sp>
+        <p:nvSpPr>
+          <p:cNvPr id="19" name="TextBox 18"/>
+          <p:cNvSpPr txBox="1"/>
+          <p:nvPr/>
+        </p:nvSpPr>
+        <p:spPr>
+          <a:xfrm>
+            <a:off x="6327648" y="4544568"/>
+            <a:ext cx="4809744" cy="365760"/>
+          </a:xfrm>
+          <a:prstGeom prst="rect">
+            <a:avLst/>
+          </a:prstGeom>
+          <a:noFill/>
+        </p:spPr>
+        <p:txBody>
+          <a:bodyPr wrap="square" anchor="t" lIns="0" rIns="0" tIns="0" bIns="0">
+            <a:spAutoFit/>
+          </a:bodyPr>
+          <a:lstStyle/>
+          <a:p>
+            <a:pPr algn="l">
+              <a:lnSpc>
+                <a:spcPct val="100000"/>
+              </a:lnSpc>
+            </a:pPr>
+            <a:r>
+              <a:rPr sz="1700" b="1" i="0">
+                <a:solidFill>
+                  <a:srgbClr val="1D1D1F"/>
+                </a:solidFill>
+                <a:latin typeface="Helvetica Neue"/>
+              </a:rPr>
+              <a:t>What We Didn't Clean</a:t>
+            </a:r>
+          </a:p>
+        </p:txBody>
+      </p:sp>
+      <p:sp>
+        <p:nvSpPr>
+          <p:cNvPr id="20" name="TextBox 19"/>
+          <p:cNvSpPr txBox="1"/>
+          <p:nvPr/>
+        </p:nvSpPr>
+        <p:spPr>
+          <a:xfrm>
+            <a:off x="6327648" y="4937760"/>
+            <a:ext cx="4809744" cy="1051560"/>
+          </a:xfrm>
+          <a:prstGeom prst="rect">
+            <a:avLst/>
+          </a:prstGeom>
+          <a:noFill/>
+        </p:spPr>
+        <p:txBody>
+          <a:bodyPr wrap="square" lIns="0" rIns="0" tIns="0" bIns="0">
+            <a:spAutoFit/>
+          </a:bodyPr>
+          <a:lstStyle/>
+          <a:p>
+            <a:pPr>
+              <a:lnSpc>
+                <a:spcPct val="108000"/>
+              </a:lnSpc>
+              <a:spcAft>
+                <a:spcPts val="700"/>
+              </a:spcAft>
+            </a:pPr>
+            <a:r>
+              <a:rPr sz="1150">
+                <a:solidFill>
+                  <a:srgbClr val="1D1D1F"/>
+                </a:solidFill>
+                <a:latin typeface="Helvetica Neue"/>
+              </a:rPr>
+              <a:t>-  Zero missing values, no malformed rows, confirmed directly across all 24,000 rows.</a:t>
+            </a:r>
+          </a:p>
+          <a:p>
+            <a:pPr>
+              <a:lnSpc>
+                <a:spcPct val="108000"/>
+              </a:lnSpc>
+              <a:spcAft>
+                <a:spcPts val="700"/>
+              </a:spcAft>
+            </a:pPr>
+            <a:r>
+              <a:rPr sz="1150">
+                <a:solidFill>
+                  <a:srgbClr val="1D1D1F"/>
+                </a:solidFill>
+                <a:latin typeface="Helvetica Neue"/>
+              </a:rPr>
+              <a:t>-  No outlier removal: large balances and payments can be genuine risk signal.</a:t>
+            </a:r>
+          </a:p>
+          <a:p>
+            <a:pPr>
+              <a:lnSpc>
+                <a:spcPct val="108000"/>
+              </a:lnSpc>
+              <a:spcAft>
+                <a:spcPts val="700"/>
+              </a:spcAft>
+            </a:pPr>
+            <a:r>
+              <a:rPr sz="1150">
+                <a:solidFill>
+                  <a:srgbClr val="1D1D1F"/>
+                </a:solidFill>
+                <a:latin typeface="Helvetica Neue"/>
+              </a:rPr>
+              <a:t>-  No resampling or class weighting: preserves the true 22.12% base rate for calibration.</a:t>
+            </a:r>
+          </a:p>
+          <a:p>
+            <a:pPr>
+              <a:lnSpc>
+                <a:spcPct val="108000"/>
+              </a:lnSpc>
+              <a:spcAft>
+                <a:spcPts val="700"/>
+              </a:spcAft>
+            </a:pPr>
+            <a:r>
+              <a:rPr sz="1150">
+                <a:solidFill>
+                  <a:srgbClr val="1D1D1F"/>
+                </a:solidFill>
+                <a:latin typeface="Helvetica Neue"/>
+              </a:rPr>
+              <a:t>-  client_id dropped as a non-informative identifier.</a:t>
+            </a:r>
+          </a:p>
+        </p:txBody>
+      </p:sp>
+      <p:sp>
+        <p:nvSpPr>
+          <p:cNvPr id="21" name="TextBox 20"/>
           <p:cNvSpPr txBox="1"/>
           <p:nvPr/>
         </p:nvSpPr>

</xml_diff>

<commit_message>
Fix fabricated feature-family chart data
feature_family_gains.png used placeholder families ("Family B"
through "Family G") with invented delta values instead of the six
real rejected feature families from REPORT.md sec1.3. Replace with the
actual families and their real OOF log-loss deltas (behavioural
signatures +0.00006, spend-as-sequence +0.00002, interaction terms
0.00000, peer-relative limit -0.00011, velocity/acceleration
-0.00024, target encoding -0.00052), matching what the Figma deck
already shows. Also fixed a label/axis overlap the new data range
exposed.
</commit_message>
<xml_diff>
--- a/presentation/finalist-presentation.pptx
+++ b/presentation/finalist-presentation.pptx
@@ -7348,8 +7348,8 @@
         </p:blipFill>
         <p:spPr>
           <a:xfrm>
-            <a:off x="6420113" y="3977639"/>
-            <a:ext cx="4990573" cy="2514600"/>
+            <a:off x="6349238" y="3977639"/>
+            <a:ext cx="5132322" cy="2514600"/>
           </a:xfrm>
           <a:prstGeom prst="rect">
             <a:avLst/>

</xml_diff>

<commit_message>
Add full feature-engineering appendix slide, fix client_id claim
Add Appendix A8 (Figma + pptx) with the complete six-family feature
breakdown verified against models/common.py::features(), including
the spend-decomposition formula and its headline result
(+0.00046 OOF / +0.00173 hidden test, the largest gain of the
project) which was missing from a separate deck being reviewed.

Also fix an imprecise claim on the Data Cleaning slide: client_id
is not simply "dropped" -- it's excluded from the feature matrix
used for modeling but explicitly carried through and required for
the submission file's ID column (common.py load(), line 157).
</commit_message>
<xml_diff>
--- a/presentation/finalist-presentation.pptx
+++ b/presentation/finalist-presentation.pptx
@@ -20,6 +20,7 @@
     <p:sldId id="268" r:id="rId20"/>
     <p:sldId id="269" r:id="rId21"/>
     <p:sldId id="270" r:id="rId22"/>
+    <p:sldId id="271" r:id="rId23"/>
   </p:sldIdLst>
   <p:sldSz cx="12191695" cy="6858000" type="screen4x3"/>
   <p:notesSz cx="6858000" cy="9144000"/>
@@ -6019,7 +6020,7 @@
 </p:sld>
 </file>
 
-<file path=ppt/slides/slide2.xml><?xml version="1.0" encoding="utf-8"?>
+<file path=ppt/slides/slide16.xml><?xml version="1.0" encoding="utf-8"?>
 <p:sld xmlns:a="http://schemas.openxmlformats.org/drawingml/2006/main" xmlns:p="http://schemas.openxmlformats.org/presentationml/2006/main" xmlns:r="http://schemas.openxmlformats.org/officeDocument/2006/relationships">
   <p:cSld>
     <p:spTree>
@@ -6081,8 +6082,8 @@
         </p:nvSpPr>
         <p:spPr>
           <a:xfrm>
-            <a:off x="640080" y="502920"/>
-            <a:ext cx="7315200" cy="365760"/>
+            <a:off x="640080" y="457200"/>
+            <a:ext cx="5486400" cy="365760"/>
           </a:xfrm>
           <a:prstGeom prst="rect">
             <a:avLst/>
@@ -6101,13 +6102,13 @@
               </a:lnSpc>
             </a:pPr>
             <a:r>
-              <a:rPr sz="1300" b="1" i="0">
+              <a:rPr sz="1250" b="1" i="0">
                 <a:solidFill>
                   <a:srgbClr val="0071E3"/>
                 </a:solidFill>
                 <a:latin typeface="Helvetica Neue"/>
               </a:rPr>
-              <a:t>PREPARATION</a:t>
+              <a:t>APPENDIX · A8</a:t>
             </a:r>
           </a:p>
         </p:txBody>
@@ -6120,7 +6121,7 @@
         </p:nvSpPr>
         <p:spPr>
           <a:xfrm>
-            <a:off x="640080" y="822960"/>
+            <a:off x="640080" y="777240"/>
             <a:ext cx="10881360" cy="914400"/>
           </a:xfrm>
           <a:prstGeom prst="rect">
@@ -6140,40 +6141,210 @@
               </a:lnSpc>
             </a:pPr>
             <a:r>
-              <a:rPr sz="3400" b="1" i="0">
+              <a:rPr sz="2800" b="1" i="0">
                 <a:solidFill>
                   <a:srgbClr val="1D1D1F"/>
                 </a:solidFill>
                 <a:latin typeface="Helvetica Neue"/>
               </a:rPr>
-              <a:t>Data Cleaning</a:t>
-            </a:r>
-          </a:p>
-        </p:txBody>
-      </p:sp>
-      <p:sp>
-        <p:nvSpPr>
-          <p:cNvPr id="5" name="Rounded Rectangle 4"/>
+              <a:t>Full feature engineering breakdown, all six families</a:t>
+            </a:r>
+          </a:p>
+        </p:txBody>
+      </p:sp>
+      <p:sp>
+        <p:nvSpPr>
+          <p:cNvPr id="5" name="TextBox 4"/>
+          <p:cNvSpPr txBox="1"/>
+          <p:nvPr/>
+        </p:nvSpPr>
+        <p:spPr>
+          <a:xfrm>
+            <a:off x="640080" y="1645920"/>
+            <a:ext cx="10911535" cy="4754880"/>
+          </a:xfrm>
+          <a:prstGeom prst="rect">
+            <a:avLst/>
+          </a:prstGeom>
+          <a:noFill/>
+        </p:spPr>
+        <p:txBody>
+          <a:bodyPr wrap="square" lIns="0" rIns="0" tIns="0" bIns="0">
+            <a:spAutoFit/>
+          </a:bodyPr>
+          <a:lstStyle/>
+          <a:p>
+            <a:pPr>
+              <a:lnSpc>
+                <a:spcPct val="108000"/>
+              </a:lnSpc>
+              <a:spcAft>
+                <a:spcPts val="1000"/>
+              </a:spcAft>
+            </a:pPr>
+            <a:r>
+              <a:rPr sz="1400">
+                <a:solidFill>
+                  <a:srgbClr val="1D1D1F"/>
+                </a:solidFill>
+                <a:latin typeface="Helvetica Neue"/>
+              </a:rPr>
+              <a:t>-  01 Repayment Status History: pay_max/sum/mean/std (lateness stats), n_late/n_late2plus (count late months), trend_pay, max_late_streak, recent_late, months_since_late, and ever_paid_full/never_used (read from the original, uncollapsed PAY codes).</a:t>
+            </a:r>
+          </a:p>
+          <a:p>
+            <a:pPr>
+              <a:lnSpc>
+                <a:spcPct val="108000"/>
+              </a:lnSpc>
+              <a:spcAft>
+                <a:spcPts val="1000"/>
+              </a:spcAft>
+            </a:pPr>
+            <a:r>
+              <a:rPr sz="1400">
+                <a:solidFill>
+                  <a:srgbClr val="1D1D1F"/>
+                </a:solidFill>
+                <a:latin typeface="Helvetica Neue"/>
+              </a:rPr>
+              <a:t>-  02 Credit Utilisation: util1-util6 (balance / limit each month), util_mean/max/trend, avail_credit (limit minus the most recent bill).</a:t>
+            </a:r>
+          </a:p>
+          <a:p>
+            <a:pPr>
+              <a:lnSpc>
+                <a:spcPct val="108000"/>
+              </a:lnSpc>
+              <a:spcAft>
+                <a:spcPts val="1000"/>
+              </a:spcAft>
+            </a:pPr>
+            <a:r>
+              <a:rPr sz="1400">
+                <a:solidFill>
+                  <a:srgbClr val="1D1D1F"/>
+                </a:solidFill>
+                <a:latin typeface="Helvetica Neue"/>
+              </a:rPr>
+              <a:t>-  03 Payment Coverage: payratio1-payratio5 (fraction of each bill actually paid), payratio_mean/min, paid_full_months, n_zero_pay.</a:t>
+            </a:r>
+          </a:p>
+          <a:p>
+            <a:pPr>
+              <a:lnSpc>
+                <a:spcPct val="108000"/>
+              </a:lnSpc>
+              <a:spcAft>
+                <a:spcPts val="1000"/>
+              </a:spcAft>
+            </a:pPr>
+            <a:r>
+              <a:rPr sz="1400">
+                <a:solidFill>
+                  <a:srgbClr val="1D1D1F"/>
+                </a:solidFill>
+                <a:latin typeface="Helvetica Neue"/>
+              </a:rPr>
+              <a:t>-  04 Levels &amp; Momentum: bill_sum/mean/std, amt_sum/mean/std, bill_growth, amt_over_limit, log_limit, restores the absolute scale the ratio families strip out, needed for the neural models (trees are scale-invariant and don't need it).</a:t>
+            </a:r>
+          </a:p>
+          <a:p>
+            <a:pPr>
+              <a:lnSpc>
+                <a:spcPct val="108000"/>
+              </a:lnSpc>
+              <a:spcAft>
+                <a:spcPts val="1000"/>
+              </a:spcAft>
+            </a:pPr>
+            <a:r>
+              <a:rPr sz="1400">
+                <a:solidFill>
+                  <a:srgbClr val="1D1D1F"/>
+                </a:solidFill>
+                <a:latin typeface="Helvetica Neue"/>
+              </a:rPr>
+              <a:t>-  05 Spending Decomposition (the largest gain of the project, +0.00046 OOF / +0.00173 hidden test): spend_t = BILL_t - BILL_(t+1) + PAY_AMT_t, plus spend1-5, spend_mean/max/std/trend, n_months_no_spend, spend_minus_paid, months_spend_gt_paid.</a:t>
+            </a:r>
+          </a:p>
+          <a:p>
+            <a:pPr>
+              <a:lnSpc>
+                <a:spcPct val="108000"/>
+              </a:lnSpc>
+              <a:spcAft>
+                <a:spcPts val="1000"/>
+              </a:spcAft>
+            </a:pPr>
+            <a:r>
+              <a:rPr sz="1400">
+                <a:solidFill>
+                  <a:srgbClr val="1D1D1F"/>
+                </a:solidFill>
+                <a:latin typeface="Helvetica Neue"/>
+              </a:rPr>
+              <a:t>-  06 Minimum-Payment Behaviour: min_pay_ratio_mean/min (distance from the assumed 10% minimum due), months_paid_about_min, months_paid_under_min.</a:t>
+            </a:r>
+          </a:p>
+          <a:p>
+            <a:pPr>
+              <a:lnSpc>
+                <a:spcPct val="108000"/>
+              </a:lnSpc>
+              <a:spcAft>
+                <a:spcPts val="1000"/>
+              </a:spcAft>
+            </a:pPr>
+            <a:r>
+              <a:rPr sz="1400">
+                <a:solidFill>
+                  <a:srgbClr val="1D1D1F"/>
+                </a:solidFill>
+                <a:latin typeface="Helvetica Neue"/>
+              </a:rPr>
+              <a:t>-  Six additional feature families were tried and rejected; see the main Feature Engineering slide for their measured deltas.</a:t>
+            </a:r>
+          </a:p>
+        </p:txBody>
+      </p:sp>
+    </p:spTree>
+  </p:cSld>
+  <p:clrMapOvr>
+    <a:masterClrMapping/>
+  </p:clrMapOvr>
+</p:sld>
+</file>
+
+<file path=ppt/slides/slide2.xml><?xml version="1.0" encoding="utf-8"?>
+<p:sld xmlns:a="http://schemas.openxmlformats.org/drawingml/2006/main" xmlns:p="http://schemas.openxmlformats.org/presentationml/2006/main" xmlns:r="http://schemas.openxmlformats.org/officeDocument/2006/relationships">
+  <p:cSld>
+    <p:spTree>
+      <p:nvGrpSpPr>
+        <p:cNvPr id="1" name=""/>
+        <p:cNvGrpSpPr/>
+        <p:nvPr/>
+      </p:nvGrpSpPr>
+      <p:grpSpPr/>
+      <p:sp>
+        <p:nvSpPr>
+          <p:cNvPr id="2" name="Rectangle 1"/>
           <p:cNvSpPr/>
           <p:nvPr/>
         </p:nvSpPr>
         <p:spPr>
           <a:xfrm>
-            <a:off x="640080" y="1600200"/>
-            <a:ext cx="5212080" cy="2148840"/>
-          </a:xfrm>
-          <a:prstGeom prst="roundRect">
-            <a:avLst>
-              <a:gd name="adj" fmla="val 4000"/>
-            </a:avLst>
+            <a:off x="0" y="0"/>
+            <a:ext cx="12191695" cy="6858000"/>
+          </a:xfrm>
+          <a:prstGeom prst="rect">
+            <a:avLst/>
           </a:prstGeom>
           <a:solidFill>
-            <a:srgbClr val="FFFFFF"/>
+            <a:srgbClr val="F5F5F7"/>
           </a:solidFill>
-          <a:ln w="12700">
-            <a:solidFill>
-              <a:srgbClr val="D2D2D7"/>
-            </a:solidFill>
+          <a:ln>
+            <a:noFill/>
           </a:ln>
           <a:effectLst/>
         </p:spPr>
@@ -6201,14 +6372,14 @@
       </p:sp>
       <p:sp>
         <p:nvSpPr>
-          <p:cNvPr id="6" name="TextBox 5"/>
-          <p:cNvSpPr txBox="1"/>
-          <p:nvPr/>
-        </p:nvSpPr>
-        <p:spPr>
-          <a:xfrm>
-            <a:off x="841248" y="1728216"/>
-            <a:ext cx="914400" cy="457200"/>
+          <p:cNvPr id="3" name="TextBox 2"/>
+          <p:cNvSpPr txBox="1"/>
+          <p:nvPr/>
+        </p:nvSpPr>
+        <p:spPr>
+          <a:xfrm>
+            <a:off x="640080" y="502920"/>
+            <a:ext cx="7315200" cy="365760"/>
           </a:xfrm>
           <a:prstGeom prst="rect">
             <a:avLst/>
@@ -6227,27 +6398,27 @@
               </a:lnSpc>
             </a:pPr>
             <a:r>
-              <a:rPr sz="3000" b="1" i="0">
-                <a:solidFill>
-                  <a:srgbClr val="D2D2D7"/>
-                </a:solidFill>
-                <a:latin typeface="Helvetica Neue"/>
-              </a:rPr>
-              <a:t>01</a:t>
-            </a:r>
-          </a:p>
-        </p:txBody>
-      </p:sp>
-      <p:sp>
-        <p:nvSpPr>
-          <p:cNvPr id="7" name="TextBox 6"/>
-          <p:cNvSpPr txBox="1"/>
-          <p:nvPr/>
-        </p:nvSpPr>
-        <p:spPr>
-          <a:xfrm>
-            <a:off x="841248" y="2167128"/>
-            <a:ext cx="4809744" cy="365760"/>
+              <a:rPr sz="1300" b="1" i="0">
+                <a:solidFill>
+                  <a:srgbClr val="0071E3"/>
+                </a:solidFill>
+                <a:latin typeface="Helvetica Neue"/>
+              </a:rPr>
+              <a:t>PREPARATION</a:t>
+            </a:r>
+          </a:p>
+        </p:txBody>
+      </p:sp>
+      <p:sp>
+        <p:nvSpPr>
+          <p:cNvPr id="4" name="TextBox 3"/>
+          <p:cNvSpPr txBox="1"/>
+          <p:nvPr/>
+        </p:nvSpPr>
+        <p:spPr>
+          <a:xfrm>
+            <a:off x="640080" y="822960"/>
+            <a:ext cx="10881360" cy="914400"/>
           </a:xfrm>
           <a:prstGeom prst="rect">
             <a:avLst/>
@@ -6266,144 +6437,26 @@
               </a:lnSpc>
             </a:pPr>
             <a:r>
-              <a:rPr sz="1700" b="1" i="0">
+              <a:rPr sz="3400" b="1" i="0">
                 <a:solidFill>
                   <a:srgbClr val="1D1D1F"/>
                 </a:solidFill>
                 <a:latin typeface="Helvetica Neue"/>
               </a:rPr>
-              <a:t>Repayment Status</a:t>
-            </a:r>
-          </a:p>
-        </p:txBody>
-      </p:sp>
-      <p:sp>
-        <p:nvSpPr>
-          <p:cNvPr id="8" name="TextBox 7"/>
-          <p:cNvSpPr txBox="1"/>
-          <p:nvPr/>
-        </p:nvSpPr>
-        <p:spPr>
-          <a:xfrm>
-            <a:off x="841248" y="2560320"/>
-            <a:ext cx="4809744" cy="1051560"/>
-          </a:xfrm>
-          <a:prstGeom prst="rect">
-            <a:avLst/>
-          </a:prstGeom>
-          <a:noFill/>
-        </p:spPr>
-        <p:txBody>
-          <a:bodyPr wrap="square" lIns="0" rIns="0" tIns="0" bIns="0">
-            <a:spAutoFit/>
-          </a:bodyPr>
-          <a:lstStyle/>
-          <a:p>
-            <a:pPr>
-              <a:lnSpc>
-                <a:spcPct val="108000"/>
-              </a:lnSpc>
-              <a:spcAft>
-                <a:spcPts val="700"/>
-              </a:spcAft>
-            </a:pPr>
-            <a:r>
-              <a:rPr sz="1150">
-                <a:solidFill>
-                  <a:srgbClr val="1D1D1F"/>
-                </a:solidFill>
-                <a:latin typeface="Helvetica Neue"/>
-              </a:rPr>
-              <a:t>-  PAY_0, PAY_2 through PAY_6 show months behind on payment.</a:t>
-            </a:r>
-          </a:p>
-          <a:p>
-            <a:pPr>
-              <a:lnSpc>
-                <a:spcPct val="108000"/>
-              </a:lnSpc>
-              <a:spcAft>
-                <a:spcPts val="700"/>
-              </a:spcAft>
-            </a:pPr>
-            <a:r>
-              <a:rPr sz="1150">
-                <a:solidFill>
-                  <a:srgbClr val="1D1D1F"/>
-                </a:solidFill>
-                <a:latin typeface="Helvetica Neue"/>
-              </a:rPr>
-              <a:t>-  -2 = no balance, -1 = paid in full, 0 = paid minimum amount.</a:t>
-            </a:r>
-          </a:p>
-          <a:p>
-            <a:pPr>
-              <a:lnSpc>
-                <a:spcPct val="108000"/>
-              </a:lnSpc>
-              <a:spcAft>
-                <a:spcPts val="700"/>
-              </a:spcAft>
-            </a:pPr>
-            <a:r>
-              <a:rPr sz="1150">
-                <a:solidFill>
-                  <a:srgbClr val="1D1D1F"/>
-                </a:solidFill>
-                <a:latin typeface="Helvetica Neue"/>
-              </a:rPr>
-              <a:t>-  Raw values stay untouched in the cleaned dataset, no grouping here.</a:t>
-            </a:r>
-          </a:p>
-          <a:p>
-            <a:pPr>
-              <a:lnSpc>
-                <a:spcPct val="108000"/>
-              </a:lnSpc>
-              <a:spcAft>
-                <a:spcPts val="700"/>
-              </a:spcAft>
-            </a:pPr>
-            <a:r>
-              <a:rPr sz="1150">
-                <a:solidFill>
-                  <a:srgbClr val="1D1D1F"/>
-                </a:solidFill>
-                <a:latin typeface="Helvetica Neue"/>
-              </a:rPr>
-              <a:t>-  Aggregate lateness features (pay_max, n_late, trend_pay) clip -2/-1/0 to 0 only.</a:t>
-            </a:r>
-          </a:p>
-          <a:p>
-            <a:pPr>
-              <a:lnSpc>
-                <a:spcPct val="108000"/>
-              </a:lnSpc>
-              <a:spcAft>
-                <a:spcPts val="700"/>
-              </a:spcAft>
-            </a:pPr>
-            <a:r>
-              <a:rPr sz="1150">
-                <a:solidFill>
-                  <a:srgbClr val="1D1D1F"/>
-                </a:solidFill>
-                <a:latin typeface="Helvetica Neue"/>
-              </a:rPr>
-              <a:t>-  ever_paid_full and never_used deliberately keep the original codes.</a:t>
-            </a:r>
-          </a:p>
-        </p:txBody>
-      </p:sp>
-      <p:sp>
-        <p:nvSpPr>
-          <p:cNvPr id="9" name="Rounded Rectangle 8"/>
+              <a:t>Data Cleaning</a:t>
+            </a:r>
+          </a:p>
+        </p:txBody>
+      </p:sp>
+      <p:sp>
+        <p:nvSpPr>
+          <p:cNvPr id="5" name="Rounded Rectangle 4"/>
           <p:cNvSpPr/>
           <p:nvPr/>
         </p:nvSpPr>
         <p:spPr>
           <a:xfrm>
-            <a:off x="6126480" y="1600200"/>
+            <a:off x="640080" y="1600200"/>
             <a:ext cx="5212080" cy="2148840"/>
           </a:xfrm>
           <a:prstGeom prst="roundRect">
@@ -6445,13 +6498,13 @@
       </p:sp>
       <p:sp>
         <p:nvSpPr>
-          <p:cNvPr id="10" name="TextBox 9"/>
-          <p:cNvSpPr txBox="1"/>
-          <p:nvPr/>
-        </p:nvSpPr>
-        <p:spPr>
-          <a:xfrm>
-            <a:off x="6327648" y="1728216"/>
+          <p:cNvPr id="6" name="TextBox 5"/>
+          <p:cNvSpPr txBox="1"/>
+          <p:nvPr/>
+        </p:nvSpPr>
+        <p:spPr>
+          <a:xfrm>
+            <a:off x="841248" y="1728216"/>
             <a:ext cx="914400" cy="457200"/>
           </a:xfrm>
           <a:prstGeom prst="rect">
@@ -6477,20 +6530,20 @@
                 </a:solidFill>
                 <a:latin typeface="Helvetica Neue"/>
               </a:rPr>
-              <a:t>02</a:t>
-            </a:r>
-          </a:p>
-        </p:txBody>
-      </p:sp>
-      <p:sp>
-        <p:nvSpPr>
-          <p:cNvPr id="11" name="TextBox 10"/>
-          <p:cNvSpPr txBox="1"/>
-          <p:nvPr/>
-        </p:nvSpPr>
-        <p:spPr>
-          <a:xfrm>
-            <a:off x="6327648" y="2167128"/>
+              <a:t>01</a:t>
+            </a:r>
+          </a:p>
+        </p:txBody>
+      </p:sp>
+      <p:sp>
+        <p:nvSpPr>
+          <p:cNvPr id="7" name="TextBox 6"/>
+          <p:cNvSpPr txBox="1"/>
+          <p:nvPr/>
+        </p:nvSpPr>
+        <p:spPr>
+          <a:xfrm>
+            <a:off x="841248" y="2167128"/>
             <a:ext cx="4809744" cy="365760"/>
           </a:xfrm>
           <a:prstGeom prst="rect">
@@ -6512,24 +6565,24 @@
             <a:r>
               <a:rPr sz="1700" b="1" i="0">
                 <a:solidFill>
-                  <a:srgbClr val="CB382D"/>
-                </a:solidFill>
-                <a:latin typeface="Helvetica Neue"/>
-              </a:rPr>
-              <a:t>Education</a:t>
-            </a:r>
-          </a:p>
-        </p:txBody>
-      </p:sp>
-      <p:sp>
-        <p:nvSpPr>
-          <p:cNvPr id="12" name="TextBox 11"/>
-          <p:cNvSpPr txBox="1"/>
-          <p:nvPr/>
-        </p:nvSpPr>
-        <p:spPr>
-          <a:xfrm>
-            <a:off x="6327648" y="2560320"/>
+                  <a:srgbClr val="1D1D1F"/>
+                </a:solidFill>
+                <a:latin typeface="Helvetica Neue"/>
+              </a:rPr>
+              <a:t>Repayment Status</a:t>
+            </a:r>
+          </a:p>
+        </p:txBody>
+      </p:sp>
+      <p:sp>
+        <p:nvSpPr>
+          <p:cNvPr id="8" name="TextBox 7"/>
+          <p:cNvSpPr txBox="1"/>
+          <p:nvPr/>
+        </p:nvSpPr>
+        <p:spPr>
+          <a:xfrm>
+            <a:off x="841248" y="2560320"/>
             <a:ext cx="4809744" cy="1051560"/>
           </a:xfrm>
           <a:prstGeom prst="rect">
@@ -6558,7 +6611,7 @@
                 </a:solidFill>
                 <a:latin typeface="Helvetica Neue"/>
               </a:rPr>
-              <a:t>-  1 = graduate school, 2 = university, 3 = high school, 4 = other (official codes).</a:t>
+              <a:t>-  PAY_0, PAY_2 through PAY_6 show months behind on payment.</a:t>
             </a:r>
           </a:p>
           <a:p>
@@ -6577,7 +6630,7 @@
                 </a:solidFill>
                 <a:latin typeface="Helvetica Neue"/>
               </a:rPr>
-              <a:t>-  Undocumented codes 0, 5, 6 folded into "other" (4), 290 rows.</a:t>
+              <a:t>-  -2 = no balance, -1 = paid in full, 0 = paid minimum amount.</a:t>
             </a:r>
           </a:p>
           <a:p>
@@ -6596,7 +6649,7 @@
                 </a:solidFill>
                 <a:latin typeface="Helvetica Neue"/>
               </a:rPr>
-              <a:t>-  Confirmed cost: "other" over-predicted about 61%, AUC 0.645 vs about 0.79 elsewhere.</a:t>
+              <a:t>-  Raw values stay untouched in the cleaned dataset, no grouping here.</a:t>
             </a:r>
           </a:p>
           <a:p>
@@ -6615,20 +6668,39 @@
                 </a:solidFill>
                 <a:latin typeface="Helvetica Neue"/>
               </a:rPr>
-              <a:t>-  The only subgroup where the model underperforms its own base rate.</a:t>
-            </a:r>
-          </a:p>
-        </p:txBody>
-      </p:sp>
-      <p:sp>
-        <p:nvSpPr>
-          <p:cNvPr id="13" name="Rounded Rectangle 12"/>
+              <a:t>-  Aggregate lateness features (pay_max, n_late, trend_pay) clip -2/-1/0 to 0 only.</a:t>
+            </a:r>
+          </a:p>
+          <a:p>
+            <a:pPr>
+              <a:lnSpc>
+                <a:spcPct val="108000"/>
+              </a:lnSpc>
+              <a:spcAft>
+                <a:spcPts val="700"/>
+              </a:spcAft>
+            </a:pPr>
+            <a:r>
+              <a:rPr sz="1150">
+                <a:solidFill>
+                  <a:srgbClr val="1D1D1F"/>
+                </a:solidFill>
+                <a:latin typeface="Helvetica Neue"/>
+              </a:rPr>
+              <a:t>-  ever_paid_full and never_used deliberately keep the original codes.</a:t>
+            </a:r>
+          </a:p>
+        </p:txBody>
+      </p:sp>
+      <p:sp>
+        <p:nvSpPr>
+          <p:cNvPr id="9" name="Rounded Rectangle 8"/>
           <p:cNvSpPr/>
           <p:nvPr/>
         </p:nvSpPr>
         <p:spPr>
           <a:xfrm>
-            <a:off x="640080" y="3977640"/>
+            <a:off x="6126480" y="1600200"/>
             <a:ext cx="5212080" cy="2148840"/>
           </a:xfrm>
           <a:prstGeom prst="roundRect">
@@ -6670,13 +6742,13 @@
       </p:sp>
       <p:sp>
         <p:nvSpPr>
-          <p:cNvPr id="14" name="TextBox 13"/>
-          <p:cNvSpPr txBox="1"/>
-          <p:nvPr/>
-        </p:nvSpPr>
-        <p:spPr>
-          <a:xfrm>
-            <a:off x="841248" y="4105656"/>
+          <p:cNvPr id="10" name="TextBox 9"/>
+          <p:cNvSpPr txBox="1"/>
+          <p:nvPr/>
+        </p:nvSpPr>
+        <p:spPr>
+          <a:xfrm>
+            <a:off x="6327648" y="1728216"/>
             <a:ext cx="914400" cy="457200"/>
           </a:xfrm>
           <a:prstGeom prst="rect">
@@ -6702,20 +6774,20 @@
                 </a:solidFill>
                 <a:latin typeface="Helvetica Neue"/>
               </a:rPr>
-              <a:t>03</a:t>
-            </a:r>
-          </a:p>
-        </p:txBody>
-      </p:sp>
-      <p:sp>
-        <p:nvSpPr>
-          <p:cNvPr id="15" name="TextBox 14"/>
-          <p:cNvSpPr txBox="1"/>
-          <p:nvPr/>
-        </p:nvSpPr>
-        <p:spPr>
-          <a:xfrm>
-            <a:off x="841248" y="4544568"/>
+              <a:t>02</a:t>
+            </a:r>
+          </a:p>
+        </p:txBody>
+      </p:sp>
+      <p:sp>
+        <p:nvSpPr>
+          <p:cNvPr id="11" name="TextBox 10"/>
+          <p:cNvSpPr txBox="1"/>
+          <p:nvPr/>
+        </p:nvSpPr>
+        <p:spPr>
+          <a:xfrm>
+            <a:off x="6327648" y="2167128"/>
             <a:ext cx="4809744" cy="365760"/>
           </a:xfrm>
           <a:prstGeom prst="rect">
@@ -6737,24 +6809,24 @@
             <a:r>
               <a:rPr sz="1700" b="1" i="0">
                 <a:solidFill>
-                  <a:srgbClr val="1D1D1F"/>
-                </a:solidFill>
-                <a:latin typeface="Helvetica Neue"/>
-              </a:rPr>
-              <a:t>Marriage</a:t>
-            </a:r>
-          </a:p>
-        </p:txBody>
-      </p:sp>
-      <p:sp>
-        <p:nvSpPr>
-          <p:cNvPr id="16" name="TextBox 15"/>
-          <p:cNvSpPr txBox="1"/>
-          <p:nvPr/>
-        </p:nvSpPr>
-        <p:spPr>
-          <a:xfrm>
-            <a:off x="841248" y="4937760"/>
+                  <a:srgbClr val="CB382D"/>
+                </a:solidFill>
+                <a:latin typeface="Helvetica Neue"/>
+              </a:rPr>
+              <a:t>Education</a:t>
+            </a:r>
+          </a:p>
+        </p:txBody>
+      </p:sp>
+      <p:sp>
+        <p:nvSpPr>
+          <p:cNvPr id="12" name="TextBox 11"/>
+          <p:cNvSpPr txBox="1"/>
+          <p:nvPr/>
+        </p:nvSpPr>
+        <p:spPr>
+          <a:xfrm>
+            <a:off x="6327648" y="2560320"/>
             <a:ext cx="4809744" cy="1051560"/>
           </a:xfrm>
           <a:prstGeom prst="rect">
@@ -6783,7 +6855,7 @@
                 </a:solidFill>
                 <a:latin typeface="Helvetica Neue"/>
               </a:rPr>
-              <a:t>-  1 = married, 2 = single, 3 = other (official codes).</a:t>
+              <a:t>-  1 = graduate school, 2 = university, 3 = high school, 4 = other (official codes).</a:t>
             </a:r>
           </a:p>
           <a:p>
@@ -6802,7 +6874,7 @@
                 </a:solidFill>
                 <a:latin typeface="Helvetica Neue"/>
               </a:rPr>
-              <a:t>-  Undocumented code 0 folded into "other" (3), 42 rows.</a:t>
+              <a:t>-  Undocumented codes 0, 5, 6 folded into "other" (4), 290 rows.</a:t>
             </a:r>
           </a:p>
           <a:p>
@@ -6821,20 +6893,39 @@
                 </a:solidFill>
                 <a:latin typeface="Helvetica Neue"/>
               </a:rPr>
-              <a:t>-  No confirmed fairness or accuracy issue for this group.</a:t>
-            </a:r>
-          </a:p>
-        </p:txBody>
-      </p:sp>
-      <p:sp>
-        <p:nvSpPr>
-          <p:cNvPr id="17" name="Rounded Rectangle 16"/>
+              <a:t>-  Confirmed cost: "other" over-predicted about 61%, AUC 0.645 vs about 0.79 elsewhere.</a:t>
+            </a:r>
+          </a:p>
+          <a:p>
+            <a:pPr>
+              <a:lnSpc>
+                <a:spcPct val="108000"/>
+              </a:lnSpc>
+              <a:spcAft>
+                <a:spcPts val="700"/>
+              </a:spcAft>
+            </a:pPr>
+            <a:r>
+              <a:rPr sz="1150">
+                <a:solidFill>
+                  <a:srgbClr val="1D1D1F"/>
+                </a:solidFill>
+                <a:latin typeface="Helvetica Neue"/>
+              </a:rPr>
+              <a:t>-  The only subgroup where the model underperforms its own base rate.</a:t>
+            </a:r>
+          </a:p>
+        </p:txBody>
+      </p:sp>
+      <p:sp>
+        <p:nvSpPr>
+          <p:cNvPr id="13" name="Rounded Rectangle 12"/>
           <p:cNvSpPr/>
           <p:nvPr/>
         </p:nvSpPr>
         <p:spPr>
           <a:xfrm>
-            <a:off x="6126480" y="3977640"/>
+            <a:off x="640080" y="3977640"/>
             <a:ext cx="5212080" cy="2148840"/>
           </a:xfrm>
           <a:prstGeom prst="roundRect">
@@ -6876,13 +6967,13 @@
       </p:sp>
       <p:sp>
         <p:nvSpPr>
-          <p:cNvPr id="18" name="TextBox 17"/>
-          <p:cNvSpPr txBox="1"/>
-          <p:nvPr/>
-        </p:nvSpPr>
-        <p:spPr>
-          <a:xfrm>
-            <a:off x="6327648" y="4105656"/>
+          <p:cNvPr id="14" name="TextBox 13"/>
+          <p:cNvSpPr txBox="1"/>
+          <p:nvPr/>
+        </p:nvSpPr>
+        <p:spPr>
+          <a:xfrm>
+            <a:off x="841248" y="4105656"/>
             <a:ext cx="914400" cy="457200"/>
           </a:xfrm>
           <a:prstGeom prst="rect">
@@ -6908,20 +6999,20 @@
                 </a:solidFill>
                 <a:latin typeface="Helvetica Neue"/>
               </a:rPr>
-              <a:t>04</a:t>
-            </a:r>
-          </a:p>
-        </p:txBody>
-      </p:sp>
-      <p:sp>
-        <p:nvSpPr>
-          <p:cNvPr id="19" name="TextBox 18"/>
-          <p:cNvSpPr txBox="1"/>
-          <p:nvPr/>
-        </p:nvSpPr>
-        <p:spPr>
-          <a:xfrm>
-            <a:off x="6327648" y="4544568"/>
+              <a:t>03</a:t>
+            </a:r>
+          </a:p>
+        </p:txBody>
+      </p:sp>
+      <p:sp>
+        <p:nvSpPr>
+          <p:cNvPr id="15" name="TextBox 14"/>
+          <p:cNvSpPr txBox="1"/>
+          <p:nvPr/>
+        </p:nvSpPr>
+        <p:spPr>
+          <a:xfrm>
+            <a:off x="841248" y="4544568"/>
             <a:ext cx="4809744" cy="365760"/>
           </a:xfrm>
           <a:prstGeom prst="rect">
@@ -6947,20 +7038,20 @@
                 </a:solidFill>
                 <a:latin typeface="Helvetica Neue"/>
               </a:rPr>
-              <a:t>What We Didn't Clean</a:t>
-            </a:r>
-          </a:p>
-        </p:txBody>
-      </p:sp>
-      <p:sp>
-        <p:nvSpPr>
-          <p:cNvPr id="20" name="TextBox 19"/>
-          <p:cNvSpPr txBox="1"/>
-          <p:nvPr/>
-        </p:nvSpPr>
-        <p:spPr>
-          <a:xfrm>
-            <a:off x="6327648" y="4937760"/>
+              <a:t>Marriage</a:t>
+            </a:r>
+          </a:p>
+        </p:txBody>
+      </p:sp>
+      <p:sp>
+        <p:nvSpPr>
+          <p:cNvPr id="16" name="TextBox 15"/>
+          <p:cNvSpPr txBox="1"/>
+          <p:nvPr/>
+        </p:nvSpPr>
+        <p:spPr>
+          <a:xfrm>
+            <a:off x="841248" y="4937760"/>
             <a:ext cx="4809744" cy="1051560"/>
           </a:xfrm>
           <a:prstGeom prst="rect">
@@ -6989,7 +7080,7 @@
                 </a:solidFill>
                 <a:latin typeface="Helvetica Neue"/>
               </a:rPr>
-              <a:t>-  Zero missing values, no malformed rows, confirmed directly across all 24,000 rows.</a:t>
+              <a:t>-  1 = married, 2 = single, 3 = other (official codes).</a:t>
             </a:r>
           </a:p>
           <a:p>
@@ -7008,7 +7099,7 @@
                 </a:solidFill>
                 <a:latin typeface="Helvetica Neue"/>
               </a:rPr>
-              <a:t>-  No outlier removal: large balances and payments can be genuine risk signal.</a:t>
+              <a:t>-  Undocumented code 0 folded into "other" (3), 42 rows.</a:t>
             </a:r>
           </a:p>
           <a:p>
@@ -7027,9 +7118,158 @@
                 </a:solidFill>
                 <a:latin typeface="Helvetica Neue"/>
               </a:rPr>
-              <a:t>-  No resampling or class weighting: preserves the true 22.12% base rate for calibration.</a:t>
-            </a:r>
-          </a:p>
+              <a:t>-  No confirmed fairness or accuracy issue for this group.</a:t>
+            </a:r>
+          </a:p>
+        </p:txBody>
+      </p:sp>
+      <p:sp>
+        <p:nvSpPr>
+          <p:cNvPr id="17" name="Rounded Rectangle 16"/>
+          <p:cNvSpPr/>
+          <p:nvPr/>
+        </p:nvSpPr>
+        <p:spPr>
+          <a:xfrm>
+            <a:off x="6126480" y="3977640"/>
+            <a:ext cx="5212080" cy="2148840"/>
+          </a:xfrm>
+          <a:prstGeom prst="roundRect">
+            <a:avLst>
+              <a:gd name="adj" fmla="val 4000"/>
+            </a:avLst>
+          </a:prstGeom>
+          <a:solidFill>
+            <a:srgbClr val="FFFFFF"/>
+          </a:solidFill>
+          <a:ln w="12700">
+            <a:solidFill>
+              <a:srgbClr val="D2D2D7"/>
+            </a:solidFill>
+          </a:ln>
+          <a:effectLst/>
+        </p:spPr>
+        <p:style>
+          <a:lnRef idx="1">
+            <a:schemeClr val="accent1"/>
+          </a:lnRef>
+          <a:fillRef idx="3">
+            <a:schemeClr val="accent1"/>
+          </a:fillRef>
+          <a:effectRef idx="2">
+            <a:schemeClr val="accent1"/>
+          </a:effectRef>
+          <a:fontRef idx="minor">
+            <a:schemeClr val="lt1"/>
+          </a:fontRef>
+        </p:style>
+        <p:txBody>
+          <a:bodyPr rtlCol="0" anchor="ctr"/>
+          <a:lstStyle/>
+          <a:p>
+            <a:pPr algn="ctr"/>
+          </a:p>
+        </p:txBody>
+      </p:sp>
+      <p:sp>
+        <p:nvSpPr>
+          <p:cNvPr id="18" name="TextBox 17"/>
+          <p:cNvSpPr txBox="1"/>
+          <p:nvPr/>
+        </p:nvSpPr>
+        <p:spPr>
+          <a:xfrm>
+            <a:off x="6327648" y="4105656"/>
+            <a:ext cx="914400" cy="457200"/>
+          </a:xfrm>
+          <a:prstGeom prst="rect">
+            <a:avLst/>
+          </a:prstGeom>
+          <a:noFill/>
+        </p:spPr>
+        <p:txBody>
+          <a:bodyPr wrap="square" anchor="t" lIns="0" rIns="0" tIns="0" bIns="0">
+            <a:spAutoFit/>
+          </a:bodyPr>
+          <a:lstStyle/>
+          <a:p>
+            <a:pPr algn="l">
+              <a:lnSpc>
+                <a:spcPct val="100000"/>
+              </a:lnSpc>
+            </a:pPr>
+            <a:r>
+              <a:rPr sz="3000" b="1" i="0">
+                <a:solidFill>
+                  <a:srgbClr val="D2D2D7"/>
+                </a:solidFill>
+                <a:latin typeface="Helvetica Neue"/>
+              </a:rPr>
+              <a:t>04</a:t>
+            </a:r>
+          </a:p>
+        </p:txBody>
+      </p:sp>
+      <p:sp>
+        <p:nvSpPr>
+          <p:cNvPr id="19" name="TextBox 18"/>
+          <p:cNvSpPr txBox="1"/>
+          <p:nvPr/>
+        </p:nvSpPr>
+        <p:spPr>
+          <a:xfrm>
+            <a:off x="6327648" y="4544568"/>
+            <a:ext cx="4809744" cy="365760"/>
+          </a:xfrm>
+          <a:prstGeom prst="rect">
+            <a:avLst/>
+          </a:prstGeom>
+          <a:noFill/>
+        </p:spPr>
+        <p:txBody>
+          <a:bodyPr wrap="square" anchor="t" lIns="0" rIns="0" tIns="0" bIns="0">
+            <a:spAutoFit/>
+          </a:bodyPr>
+          <a:lstStyle/>
+          <a:p>
+            <a:pPr algn="l">
+              <a:lnSpc>
+                <a:spcPct val="100000"/>
+              </a:lnSpc>
+            </a:pPr>
+            <a:r>
+              <a:rPr sz="1700" b="1" i="0">
+                <a:solidFill>
+                  <a:srgbClr val="1D1D1F"/>
+                </a:solidFill>
+                <a:latin typeface="Helvetica Neue"/>
+              </a:rPr>
+              <a:t>What We Didn't Clean</a:t>
+            </a:r>
+          </a:p>
+        </p:txBody>
+      </p:sp>
+      <p:sp>
+        <p:nvSpPr>
+          <p:cNvPr id="20" name="TextBox 19"/>
+          <p:cNvSpPr txBox="1"/>
+          <p:nvPr/>
+        </p:nvSpPr>
+        <p:spPr>
+          <a:xfrm>
+            <a:off x="6327648" y="4937760"/>
+            <a:ext cx="4809744" cy="1051560"/>
+          </a:xfrm>
+          <a:prstGeom prst="rect">
+            <a:avLst/>
+          </a:prstGeom>
+          <a:noFill/>
+        </p:spPr>
+        <p:txBody>
+          <a:bodyPr wrap="square" lIns="0" rIns="0" tIns="0" bIns="0">
+            <a:spAutoFit/>
+          </a:bodyPr>
+          <a:lstStyle/>
           <a:p>
             <a:pPr>
               <a:lnSpc>
@@ -7046,7 +7286,64 @@
                 </a:solidFill>
                 <a:latin typeface="Helvetica Neue"/>
               </a:rPr>
-              <a:t>-  client_id dropped as a non-informative identifier.</a:t>
+              <a:t>-  Zero missing values, no malformed rows, confirmed directly across all 24,000 rows.</a:t>
+            </a:r>
+          </a:p>
+          <a:p>
+            <a:pPr>
+              <a:lnSpc>
+                <a:spcPct val="108000"/>
+              </a:lnSpc>
+              <a:spcAft>
+                <a:spcPts val="700"/>
+              </a:spcAft>
+            </a:pPr>
+            <a:r>
+              <a:rPr sz="1150">
+                <a:solidFill>
+                  <a:srgbClr val="1D1D1F"/>
+                </a:solidFill>
+                <a:latin typeface="Helvetica Neue"/>
+              </a:rPr>
+              <a:t>-  No outlier removal: large balances and payments can be genuine risk signal.</a:t>
+            </a:r>
+          </a:p>
+          <a:p>
+            <a:pPr>
+              <a:lnSpc>
+                <a:spcPct val="108000"/>
+              </a:lnSpc>
+              <a:spcAft>
+                <a:spcPts val="700"/>
+              </a:spcAft>
+            </a:pPr>
+            <a:r>
+              <a:rPr sz="1150">
+                <a:solidFill>
+                  <a:srgbClr val="1D1D1F"/>
+                </a:solidFill>
+                <a:latin typeface="Helvetica Neue"/>
+              </a:rPr>
+              <a:t>-  No resampling or class weighting: preserves the true 22.12% base rate for calibration.</a:t>
+            </a:r>
+          </a:p>
+          <a:p>
+            <a:pPr>
+              <a:lnSpc>
+                <a:spcPct val="108000"/>
+              </a:lnSpc>
+              <a:spcAft>
+                <a:spcPts val="700"/>
+              </a:spcAft>
+            </a:pPr>
+            <a:r>
+              <a:rPr sz="1150">
+                <a:solidFill>
+                  <a:srgbClr val="1D1D1F"/>
+                </a:solidFill>
+                <a:latin typeface="Helvetica Neue"/>
+              </a:rPr>
+              <a:t>-  client_id excluded from the feature matrix (not predictive), kept for the submission's ID column.</a:t>
             </a:r>
           </a:p>
         </p:txBody>

</xml_diff>

<commit_message>
Rebuild Feature Engineering slide as a full 6-family card grid
Move the complete, code-verified six-family breakdown onto the main
slide (not just an appendix) per feedback that the main slide was
missing information present in a comparison deck. Each bullet now
leads with plain language and keeps the code identifier (pay_max,
util1-6, etc.) as a parenthetical reference rather than leading with
it. Fixes the "Levels & Momentum" card, which previously implied
trees don't receive these features; they do (same shared 81-feature
matrix across LightGBM/GRU/TabPFN), they just don't need them since
tree splits ignore monotonic rescaling. Removes the now-redundant
appendix A8 slide. Applied to both Figma and pptx.
</commit_message>
<xml_diff>
--- a/presentation/finalist-presentation.pptx
+++ b/presentation/finalist-presentation.pptx
@@ -7483,7 +7483,7 @@
                 </a:solidFill>
                 <a:latin typeface="Helvetica Neue"/>
               </a:rPr>
-              <a:t>THE LARGEST SINGLE GAIN</a:t>
+              <a:t>SIX FAMILIES, ONE STANDOUT</a:t>
             </a:r>
           </a:p>
         </p:txBody>
@@ -7516,7 +7516,7 @@
               </a:lnSpc>
             </a:pPr>
             <a:r>
-              <a:rPr sz="3400" b="1" i="0">
+              <a:rPr sz="3200" b="1" i="0">
                 <a:solidFill>
                   <a:srgbClr val="1D1D1F"/>
                 </a:solidFill>
@@ -7535,8 +7535,95 @@
         </p:nvSpPr>
         <p:spPr>
           <a:xfrm>
+            <a:off x="640080" y="1234440"/>
+            <a:ext cx="10881360" cy="320040"/>
+          </a:xfrm>
+          <a:prstGeom prst="rect">
+            <a:avLst/>
+          </a:prstGeom>
+          <a:noFill/>
+        </p:spPr>
+        <p:txBody>
+          <a:bodyPr wrap="square" anchor="t" lIns="0" rIns="0" tIns="0" bIns="0">
+            <a:spAutoFit/>
+          </a:bodyPr>
+          <a:lstStyle/>
+          <a:p>
+            <a:pPr algn="l">
+              <a:lnSpc>
+                <a:spcPct val="100000"/>
+              </a:lnSpc>
+            </a:pPr>
+            <a:r>
+              <a:rPr sz="1450" b="0" i="0">
+                <a:solidFill>
+                  <a:srgbClr val="6E6E73"/>
+                </a:solidFill>
+                <a:latin typeface="Helvetica Neue"/>
+              </a:rPr>
+              <a:t>23 raw columns became 81 features across six families.</a:t>
+            </a:r>
+          </a:p>
+        </p:txBody>
+      </p:sp>
+      <p:sp>
+        <p:nvSpPr>
+          <p:cNvPr id="6" name="Rounded Rectangle 5"/>
+          <p:cNvSpPr/>
+          <p:nvPr/>
+        </p:nvSpPr>
+        <p:spPr>
+          <a:xfrm>
             <a:off x="640080" y="1691640"/>
-            <a:ext cx="10881360" cy="502920"/>
+            <a:ext cx="3456432" cy="2331720"/>
+          </a:xfrm>
+          <a:prstGeom prst="roundRect">
+            <a:avLst>
+              <a:gd name="adj" fmla="val 5000"/>
+            </a:avLst>
+          </a:prstGeom>
+          <a:solidFill>
+            <a:srgbClr val="FFFFFF"/>
+          </a:solidFill>
+          <a:ln w="12700">
+            <a:solidFill>
+              <a:srgbClr val="D2D2D7"/>
+            </a:solidFill>
+          </a:ln>
+          <a:effectLst/>
+        </p:spPr>
+        <p:style>
+          <a:lnRef idx="1">
+            <a:schemeClr val="accent1"/>
+          </a:lnRef>
+          <a:fillRef idx="3">
+            <a:schemeClr val="accent1"/>
+          </a:fillRef>
+          <a:effectRef idx="2">
+            <a:schemeClr val="accent1"/>
+          </a:effectRef>
+          <a:fontRef idx="minor">
+            <a:schemeClr val="lt1"/>
+          </a:fontRef>
+        </p:style>
+        <p:txBody>
+          <a:bodyPr rtlCol="0" anchor="ctr"/>
+          <a:lstStyle/>
+          <a:p>
+            <a:pPr algn="ctr"/>
+          </a:p>
+        </p:txBody>
+      </p:sp>
+      <p:sp>
+        <p:nvSpPr>
+          <p:cNvPr id="7" name="TextBox 6"/>
+          <p:cNvSpPr txBox="1"/>
+          <p:nvPr/>
+        </p:nvSpPr>
+        <p:spPr>
+          <a:xfrm>
+            <a:off x="768096" y="1764792"/>
+            <a:ext cx="548640" cy="274320"/>
           </a:xfrm>
           <a:prstGeom prst="rect">
             <a:avLst/>
@@ -7555,162 +7642,1284 @@
               </a:lnSpc>
             </a:pPr>
             <a:r>
-              <a:rPr sz="1700" b="0" i="0">
+              <a:rPr sz="1600" b="1" i="0">
+                <a:solidFill>
+                  <a:srgbClr val="D2D2D7"/>
+                </a:solidFill>
+                <a:latin typeface="Helvetica Neue"/>
+              </a:rPr>
+              <a:t>01</a:t>
+            </a:r>
+          </a:p>
+        </p:txBody>
+      </p:sp>
+      <p:sp>
+        <p:nvSpPr>
+          <p:cNvPr id="8" name="TextBox 7"/>
+          <p:cNvSpPr txBox="1"/>
+          <p:nvPr/>
+        </p:nvSpPr>
+        <p:spPr>
+          <a:xfrm>
+            <a:off x="768096" y="2002536"/>
+            <a:ext cx="3200400" cy="256032"/>
+          </a:xfrm>
+          <a:prstGeom prst="rect">
+            <a:avLst/>
+          </a:prstGeom>
+          <a:noFill/>
+        </p:spPr>
+        <p:txBody>
+          <a:bodyPr wrap="square" anchor="t" lIns="0" rIns="0" tIns="0" bIns="0">
+            <a:spAutoFit/>
+          </a:bodyPr>
+          <a:lstStyle/>
+          <a:p>
+            <a:pPr algn="l">
+              <a:lnSpc>
+                <a:spcPct val="100000"/>
+              </a:lnSpc>
+            </a:pPr>
+            <a:r>
+              <a:rPr sz="1150" b="1" i="0">
+                <a:solidFill>
+                  <a:srgbClr val="1D1D1F"/>
+                </a:solidFill>
+                <a:latin typeface="Helvetica Neue"/>
+              </a:rPr>
+              <a:t>Repayment Status History</a:t>
+            </a:r>
+          </a:p>
+        </p:txBody>
+      </p:sp>
+      <p:sp>
+        <p:nvSpPr>
+          <p:cNvPr id="9" name="TextBox 8"/>
+          <p:cNvSpPr txBox="1"/>
+          <p:nvPr/>
+        </p:nvSpPr>
+        <p:spPr>
+          <a:xfrm>
+            <a:off x="768096" y="2276856"/>
+            <a:ext cx="3200400" cy="1691640"/>
+          </a:xfrm>
+          <a:prstGeom prst="rect">
+            <a:avLst/>
+          </a:prstGeom>
+          <a:noFill/>
+        </p:spPr>
+        <p:txBody>
+          <a:bodyPr wrap="square" lIns="0" rIns="0" tIns="0" bIns="0">
+            <a:spAutoFit/>
+          </a:bodyPr>
+          <a:lstStyle/>
+          <a:p>
+            <a:pPr>
+              <a:lnSpc>
+                <a:spcPct val="108000"/>
+              </a:lnSpc>
+              <a:spcAft>
+                <a:spcPts val="400"/>
+              </a:spcAft>
+            </a:pPr>
+            <a:r>
+              <a:rPr sz="800">
+                <a:solidFill>
+                  <a:srgbClr val="1D1D1F"/>
+                </a:solidFill>
+                <a:latin typeface="Helvetica Neue"/>
+              </a:rPr>
+              <a:t>-  Worst and average lateness across the 6 months (pay_max, pay_mean).</a:t>
+            </a:r>
+          </a:p>
+          <a:p>
+            <a:pPr>
+              <a:lnSpc>
+                <a:spcPct val="108000"/>
+              </a:lnSpc>
+              <a:spcAft>
+                <a:spcPts val="400"/>
+              </a:spcAft>
+            </a:pPr>
+            <a:r>
+              <a:rPr sz="800">
+                <a:solidFill>
+                  <a:srgbClr val="1D1D1F"/>
+                </a:solidFill>
+                <a:latin typeface="Helvetica Neue"/>
+              </a:rPr>
+              <a:t>-  Number of late months, and months 2+ behind (n_late, n_late2plus).</a:t>
+            </a:r>
+          </a:p>
+          <a:p>
+            <a:pPr>
+              <a:lnSpc>
+                <a:spcPct val="108000"/>
+              </a:lnSpc>
+              <a:spcAft>
+                <a:spcPts val="400"/>
+              </a:spcAft>
+            </a:pPr>
+            <a:r>
+              <a:rPr sz="800">
+                <a:solidFill>
+                  <a:srgbClr val="1D1D1F"/>
+                </a:solidFill>
+                <a:latin typeface="Helvetica Neue"/>
+              </a:rPr>
+              <a:t>-  Trend: improving or worsening, plus longest late streak (trend_pay, max_late_streak).</a:t>
+            </a:r>
+          </a:p>
+          <a:p>
+            <a:pPr>
+              <a:lnSpc>
+                <a:spcPct val="108000"/>
+              </a:lnSpc>
+              <a:spcAft>
+                <a:spcPts val="400"/>
+              </a:spcAft>
+            </a:pPr>
+            <a:r>
+              <a:rPr sz="800">
+                <a:solidFill>
+                  <a:srgbClr val="1D1D1F"/>
+                </a:solidFill>
+                <a:latin typeface="Helvetica Neue"/>
+              </a:rPr>
+              <a:t>-  How recently they were late, weighted to the last 2 months (recent_late, months_since_late).</a:t>
+            </a:r>
+          </a:p>
+          <a:p>
+            <a:pPr>
+              <a:lnSpc>
+                <a:spcPct val="108000"/>
+              </a:lnSpc>
+              <a:spcAft>
+                <a:spcPts val="400"/>
+              </a:spcAft>
+            </a:pPr>
+            <a:r>
+              <a:rPr sz="800">
+                <a:solidFill>
+                  <a:srgbClr val="1D1D1F"/>
+                </a:solidFill>
+                <a:latin typeface="Helvetica Neue"/>
+              </a:rPr>
+              <a:t>-  Ever paid in full, or never used the card (ever_paid_full, never_used).</a:t>
+            </a:r>
+          </a:p>
+        </p:txBody>
+      </p:sp>
+      <p:sp>
+        <p:nvSpPr>
+          <p:cNvPr id="10" name="Rounded Rectangle 9"/>
+          <p:cNvSpPr/>
+          <p:nvPr/>
+        </p:nvSpPr>
+        <p:spPr>
+          <a:xfrm>
+            <a:off x="4242816" y="1691640"/>
+            <a:ext cx="3456432" cy="2331720"/>
+          </a:xfrm>
+          <a:prstGeom prst="roundRect">
+            <a:avLst>
+              <a:gd name="adj" fmla="val 5000"/>
+            </a:avLst>
+          </a:prstGeom>
+          <a:solidFill>
+            <a:srgbClr val="FFFFFF"/>
+          </a:solidFill>
+          <a:ln w="12700">
+            <a:solidFill>
+              <a:srgbClr val="D2D2D7"/>
+            </a:solidFill>
+          </a:ln>
+          <a:effectLst/>
+        </p:spPr>
+        <p:style>
+          <a:lnRef idx="1">
+            <a:schemeClr val="accent1"/>
+          </a:lnRef>
+          <a:fillRef idx="3">
+            <a:schemeClr val="accent1"/>
+          </a:fillRef>
+          <a:effectRef idx="2">
+            <a:schemeClr val="accent1"/>
+          </a:effectRef>
+          <a:fontRef idx="minor">
+            <a:schemeClr val="lt1"/>
+          </a:fontRef>
+        </p:style>
+        <p:txBody>
+          <a:bodyPr rtlCol="0" anchor="ctr"/>
+          <a:lstStyle/>
+          <a:p>
+            <a:pPr algn="ctr"/>
+          </a:p>
+        </p:txBody>
+      </p:sp>
+      <p:sp>
+        <p:nvSpPr>
+          <p:cNvPr id="11" name="TextBox 10"/>
+          <p:cNvSpPr txBox="1"/>
+          <p:nvPr/>
+        </p:nvSpPr>
+        <p:spPr>
+          <a:xfrm>
+            <a:off x="4370832" y="1764792"/>
+            <a:ext cx="548640" cy="274320"/>
+          </a:xfrm>
+          <a:prstGeom prst="rect">
+            <a:avLst/>
+          </a:prstGeom>
+          <a:noFill/>
+        </p:spPr>
+        <p:txBody>
+          <a:bodyPr wrap="square" anchor="t" lIns="0" rIns="0" tIns="0" bIns="0">
+            <a:spAutoFit/>
+          </a:bodyPr>
+          <a:lstStyle/>
+          <a:p>
+            <a:pPr algn="l">
+              <a:lnSpc>
+                <a:spcPct val="100000"/>
+              </a:lnSpc>
+            </a:pPr>
+            <a:r>
+              <a:rPr sz="1600" b="1" i="0">
+                <a:solidFill>
+                  <a:srgbClr val="D2D2D7"/>
+                </a:solidFill>
+                <a:latin typeface="Helvetica Neue"/>
+              </a:rPr>
+              <a:t>02</a:t>
+            </a:r>
+          </a:p>
+        </p:txBody>
+      </p:sp>
+      <p:sp>
+        <p:nvSpPr>
+          <p:cNvPr id="12" name="TextBox 11"/>
+          <p:cNvSpPr txBox="1"/>
+          <p:nvPr/>
+        </p:nvSpPr>
+        <p:spPr>
+          <a:xfrm>
+            <a:off x="4370832" y="2002536"/>
+            <a:ext cx="3200400" cy="256032"/>
+          </a:xfrm>
+          <a:prstGeom prst="rect">
+            <a:avLst/>
+          </a:prstGeom>
+          <a:noFill/>
+        </p:spPr>
+        <p:txBody>
+          <a:bodyPr wrap="square" anchor="t" lIns="0" rIns="0" tIns="0" bIns="0">
+            <a:spAutoFit/>
+          </a:bodyPr>
+          <a:lstStyle/>
+          <a:p>
+            <a:pPr algn="l">
+              <a:lnSpc>
+                <a:spcPct val="100000"/>
+              </a:lnSpc>
+            </a:pPr>
+            <a:r>
+              <a:rPr sz="1150" b="1" i="0">
+                <a:solidFill>
+                  <a:srgbClr val="1D1D1F"/>
+                </a:solidFill>
+                <a:latin typeface="Helvetica Neue"/>
+              </a:rPr>
+              <a:t>Credit Utilisation</a:t>
+            </a:r>
+          </a:p>
+        </p:txBody>
+      </p:sp>
+      <p:sp>
+        <p:nvSpPr>
+          <p:cNvPr id="13" name="TextBox 12"/>
+          <p:cNvSpPr txBox="1"/>
+          <p:nvPr/>
+        </p:nvSpPr>
+        <p:spPr>
+          <a:xfrm>
+            <a:off x="4370832" y="2276856"/>
+            <a:ext cx="3200400" cy="1691640"/>
+          </a:xfrm>
+          <a:prstGeom prst="rect">
+            <a:avLst/>
+          </a:prstGeom>
+          <a:noFill/>
+        </p:spPr>
+        <p:txBody>
+          <a:bodyPr wrap="square" lIns="0" rIns="0" tIns="0" bIns="0">
+            <a:spAutoFit/>
+          </a:bodyPr>
+          <a:lstStyle/>
+          <a:p>
+            <a:pPr>
+              <a:lnSpc>
+                <a:spcPct val="108000"/>
+              </a:lnSpc>
+              <a:spcAft>
+                <a:spcPts val="400"/>
+              </a:spcAft>
+            </a:pPr>
+            <a:r>
+              <a:rPr sz="800">
+                <a:solidFill>
+                  <a:srgbClr val="1D1D1F"/>
+                </a:solidFill>
+                <a:latin typeface="Helvetica Neue"/>
+              </a:rPr>
+              <a:t>-  Share of the credit limit used up, each of the 6 months (util1-util6).</a:t>
+            </a:r>
+          </a:p>
+          <a:p>
+            <a:pPr>
+              <a:lnSpc>
+                <a:spcPct val="108000"/>
+              </a:lnSpc>
+              <a:spcAft>
+                <a:spcPts val="400"/>
+              </a:spcAft>
+            </a:pPr>
+            <a:r>
+              <a:rPr sz="800">
+                <a:solidFill>
+                  <a:srgbClr val="1D1D1F"/>
+                </a:solidFill>
+                <a:latin typeface="Helvetica Neue"/>
+              </a:rPr>
+              <a:t>-  Average and peak usage, rising or falling (util_mean, util_max, util_trend).</a:t>
+            </a:r>
+          </a:p>
+          <a:p>
+            <a:pPr>
+              <a:lnSpc>
+                <a:spcPct val="108000"/>
+              </a:lnSpc>
+              <a:spcAft>
+                <a:spcPts val="400"/>
+              </a:spcAft>
+            </a:pPr>
+            <a:r>
+              <a:rPr sz="800">
+                <a:solidFill>
+                  <a:srgbClr val="1D1D1F"/>
+                </a:solidFill>
+                <a:latin typeface="Helvetica Neue"/>
+              </a:rPr>
+              <a:t>-  Actual dollars of credit still available (avail_credit).</a:t>
+            </a:r>
+          </a:p>
+        </p:txBody>
+      </p:sp>
+      <p:sp>
+        <p:nvSpPr>
+          <p:cNvPr id="14" name="Rounded Rectangle 13"/>
+          <p:cNvSpPr/>
+          <p:nvPr/>
+        </p:nvSpPr>
+        <p:spPr>
+          <a:xfrm>
+            <a:off x="7845552" y="1691640"/>
+            <a:ext cx="3456432" cy="2331720"/>
+          </a:xfrm>
+          <a:prstGeom prst="roundRect">
+            <a:avLst>
+              <a:gd name="adj" fmla="val 5000"/>
+            </a:avLst>
+          </a:prstGeom>
+          <a:solidFill>
+            <a:srgbClr val="FFFFFF"/>
+          </a:solidFill>
+          <a:ln w="12700">
+            <a:solidFill>
+              <a:srgbClr val="D2D2D7"/>
+            </a:solidFill>
+          </a:ln>
+          <a:effectLst/>
+        </p:spPr>
+        <p:style>
+          <a:lnRef idx="1">
+            <a:schemeClr val="accent1"/>
+          </a:lnRef>
+          <a:fillRef idx="3">
+            <a:schemeClr val="accent1"/>
+          </a:fillRef>
+          <a:effectRef idx="2">
+            <a:schemeClr val="accent1"/>
+          </a:effectRef>
+          <a:fontRef idx="minor">
+            <a:schemeClr val="lt1"/>
+          </a:fontRef>
+        </p:style>
+        <p:txBody>
+          <a:bodyPr rtlCol="0" anchor="ctr"/>
+          <a:lstStyle/>
+          <a:p>
+            <a:pPr algn="ctr"/>
+          </a:p>
+        </p:txBody>
+      </p:sp>
+      <p:sp>
+        <p:nvSpPr>
+          <p:cNvPr id="15" name="TextBox 14"/>
+          <p:cNvSpPr txBox="1"/>
+          <p:nvPr/>
+        </p:nvSpPr>
+        <p:spPr>
+          <a:xfrm>
+            <a:off x="7973568" y="1764792"/>
+            <a:ext cx="548640" cy="274320"/>
+          </a:xfrm>
+          <a:prstGeom prst="rect">
+            <a:avLst/>
+          </a:prstGeom>
+          <a:noFill/>
+        </p:spPr>
+        <p:txBody>
+          <a:bodyPr wrap="square" anchor="t" lIns="0" rIns="0" tIns="0" bIns="0">
+            <a:spAutoFit/>
+          </a:bodyPr>
+          <a:lstStyle/>
+          <a:p>
+            <a:pPr algn="l">
+              <a:lnSpc>
+                <a:spcPct val="100000"/>
+              </a:lnSpc>
+            </a:pPr>
+            <a:r>
+              <a:rPr sz="1600" b="1" i="0">
+                <a:solidFill>
+                  <a:srgbClr val="D2D2D7"/>
+                </a:solidFill>
+                <a:latin typeface="Helvetica Neue"/>
+              </a:rPr>
+              <a:t>03</a:t>
+            </a:r>
+          </a:p>
+        </p:txBody>
+      </p:sp>
+      <p:sp>
+        <p:nvSpPr>
+          <p:cNvPr id="16" name="TextBox 15"/>
+          <p:cNvSpPr txBox="1"/>
+          <p:nvPr/>
+        </p:nvSpPr>
+        <p:spPr>
+          <a:xfrm>
+            <a:off x="7973568" y="2002536"/>
+            <a:ext cx="3200400" cy="256032"/>
+          </a:xfrm>
+          <a:prstGeom prst="rect">
+            <a:avLst/>
+          </a:prstGeom>
+          <a:noFill/>
+        </p:spPr>
+        <p:txBody>
+          <a:bodyPr wrap="square" anchor="t" lIns="0" rIns="0" tIns="0" bIns="0">
+            <a:spAutoFit/>
+          </a:bodyPr>
+          <a:lstStyle/>
+          <a:p>
+            <a:pPr algn="l">
+              <a:lnSpc>
+                <a:spcPct val="100000"/>
+              </a:lnSpc>
+            </a:pPr>
+            <a:r>
+              <a:rPr sz="1150" b="1" i="0">
+                <a:solidFill>
+                  <a:srgbClr val="1D1D1F"/>
+                </a:solidFill>
+                <a:latin typeface="Helvetica Neue"/>
+              </a:rPr>
+              <a:t>Payment Coverage</a:t>
+            </a:r>
+          </a:p>
+        </p:txBody>
+      </p:sp>
+      <p:sp>
+        <p:nvSpPr>
+          <p:cNvPr id="17" name="TextBox 16"/>
+          <p:cNvSpPr txBox="1"/>
+          <p:nvPr/>
+        </p:nvSpPr>
+        <p:spPr>
+          <a:xfrm>
+            <a:off x="7973568" y="2276856"/>
+            <a:ext cx="3200400" cy="1691640"/>
+          </a:xfrm>
+          <a:prstGeom prst="rect">
+            <a:avLst/>
+          </a:prstGeom>
+          <a:noFill/>
+        </p:spPr>
+        <p:txBody>
+          <a:bodyPr wrap="square" lIns="0" rIns="0" tIns="0" bIns="0">
+            <a:spAutoFit/>
+          </a:bodyPr>
+          <a:lstStyle/>
+          <a:p>
+            <a:pPr>
+              <a:lnSpc>
+                <a:spcPct val="108000"/>
+              </a:lnSpc>
+              <a:spcAft>
+                <a:spcPts val="400"/>
+              </a:spcAft>
+            </a:pPr>
+            <a:r>
+              <a:rPr sz="800">
+                <a:solidFill>
+                  <a:srgbClr val="1D1D1F"/>
+                </a:solidFill>
+                <a:latin typeface="Helvetica Neue"/>
+              </a:rPr>
+              <a:t>-  Fraction of each month's bill actually paid off (payratio1-payratio5).</a:t>
+            </a:r>
+          </a:p>
+          <a:p>
+            <a:pPr>
+              <a:lnSpc>
+                <a:spcPct val="108000"/>
+              </a:lnSpc>
+              <a:spcAft>
+                <a:spcPts val="400"/>
+              </a:spcAft>
+            </a:pPr>
+            <a:r>
+              <a:rPr sz="800">
+                <a:solidFill>
+                  <a:srgbClr val="1D1D1F"/>
+                </a:solidFill>
+                <a:latin typeface="Helvetica Neue"/>
+              </a:rPr>
+              <a:t>-  Average and worst month's payment coverage (payratio_mean, payratio_min).</a:t>
+            </a:r>
+          </a:p>
+          <a:p>
+            <a:pPr>
+              <a:lnSpc>
+                <a:spcPct val="108000"/>
+              </a:lnSpc>
+              <a:spcAft>
+                <a:spcPts val="400"/>
+              </a:spcAft>
+            </a:pPr>
+            <a:r>
+              <a:rPr sz="800">
+                <a:solidFill>
+                  <a:srgbClr val="1D1D1F"/>
+                </a:solidFill>
+                <a:latin typeface="Helvetica Neue"/>
+              </a:rPr>
+              <a:t>-  Months paid in full, and months paid nothing (paid_full_months, n_zero_pay).</a:t>
+            </a:r>
+          </a:p>
+          <a:p>
+            <a:pPr>
+              <a:lnSpc>
+                <a:spcPct val="108000"/>
+              </a:lnSpc>
+              <a:spcAft>
+                <a:spcPts val="400"/>
+              </a:spcAft>
+            </a:pPr>
+            <a:r>
+              <a:rPr sz="800">
+                <a:solidFill>
+                  <a:srgbClr val="1D1D1F"/>
+                </a:solidFill>
+                <a:latin typeface="Helvetica Neue"/>
+              </a:rPr>
+              <a:t>-  Hypothesis: paying a higher share each month predicts lower risk.</a:t>
+            </a:r>
+          </a:p>
+        </p:txBody>
+      </p:sp>
+      <p:sp>
+        <p:nvSpPr>
+          <p:cNvPr id="18" name="Rounded Rectangle 17"/>
+          <p:cNvSpPr/>
+          <p:nvPr/>
+        </p:nvSpPr>
+        <p:spPr>
+          <a:xfrm>
+            <a:off x="640080" y="4151376"/>
+            <a:ext cx="3456432" cy="2331720"/>
+          </a:xfrm>
+          <a:prstGeom prst="roundRect">
+            <a:avLst>
+              <a:gd name="adj" fmla="val 5000"/>
+            </a:avLst>
+          </a:prstGeom>
+          <a:solidFill>
+            <a:srgbClr val="FFFFFF"/>
+          </a:solidFill>
+          <a:ln w="12700">
+            <a:solidFill>
+              <a:srgbClr val="D2D2D7"/>
+            </a:solidFill>
+          </a:ln>
+          <a:effectLst/>
+        </p:spPr>
+        <p:style>
+          <a:lnRef idx="1">
+            <a:schemeClr val="accent1"/>
+          </a:lnRef>
+          <a:fillRef idx="3">
+            <a:schemeClr val="accent1"/>
+          </a:fillRef>
+          <a:effectRef idx="2">
+            <a:schemeClr val="accent1"/>
+          </a:effectRef>
+          <a:fontRef idx="minor">
+            <a:schemeClr val="lt1"/>
+          </a:fontRef>
+        </p:style>
+        <p:txBody>
+          <a:bodyPr rtlCol="0" anchor="ctr"/>
+          <a:lstStyle/>
+          <a:p>
+            <a:pPr algn="ctr"/>
+          </a:p>
+        </p:txBody>
+      </p:sp>
+      <p:sp>
+        <p:nvSpPr>
+          <p:cNvPr id="19" name="TextBox 18"/>
+          <p:cNvSpPr txBox="1"/>
+          <p:nvPr/>
+        </p:nvSpPr>
+        <p:spPr>
+          <a:xfrm>
+            <a:off x="768096" y="4224528"/>
+            <a:ext cx="548640" cy="274320"/>
+          </a:xfrm>
+          <a:prstGeom prst="rect">
+            <a:avLst/>
+          </a:prstGeom>
+          <a:noFill/>
+        </p:spPr>
+        <p:txBody>
+          <a:bodyPr wrap="square" anchor="t" lIns="0" rIns="0" tIns="0" bIns="0">
+            <a:spAutoFit/>
+          </a:bodyPr>
+          <a:lstStyle/>
+          <a:p>
+            <a:pPr algn="l">
+              <a:lnSpc>
+                <a:spcPct val="100000"/>
+              </a:lnSpc>
+            </a:pPr>
+            <a:r>
+              <a:rPr sz="1600" b="1" i="0">
+                <a:solidFill>
+                  <a:srgbClr val="D2D2D7"/>
+                </a:solidFill>
+                <a:latin typeface="Helvetica Neue"/>
+              </a:rPr>
+              <a:t>04</a:t>
+            </a:r>
+          </a:p>
+        </p:txBody>
+      </p:sp>
+      <p:sp>
+        <p:nvSpPr>
+          <p:cNvPr id="20" name="TextBox 19"/>
+          <p:cNvSpPr txBox="1"/>
+          <p:nvPr/>
+        </p:nvSpPr>
+        <p:spPr>
+          <a:xfrm>
+            <a:off x="768096" y="4462272"/>
+            <a:ext cx="3200400" cy="256032"/>
+          </a:xfrm>
+          <a:prstGeom prst="rect">
+            <a:avLst/>
+          </a:prstGeom>
+          <a:noFill/>
+        </p:spPr>
+        <p:txBody>
+          <a:bodyPr wrap="square" anchor="t" lIns="0" rIns="0" tIns="0" bIns="0">
+            <a:spAutoFit/>
+          </a:bodyPr>
+          <a:lstStyle/>
+          <a:p>
+            <a:pPr algn="l">
+              <a:lnSpc>
+                <a:spcPct val="100000"/>
+              </a:lnSpc>
+            </a:pPr>
+            <a:r>
+              <a:rPr sz="1150" b="1" i="0">
+                <a:solidFill>
+                  <a:srgbClr val="1D1D1F"/>
+                </a:solidFill>
+                <a:latin typeface="Helvetica Neue"/>
+              </a:rPr>
+              <a:t>Levels &amp; Momentum</a:t>
+            </a:r>
+          </a:p>
+        </p:txBody>
+      </p:sp>
+      <p:sp>
+        <p:nvSpPr>
+          <p:cNvPr id="21" name="TextBox 20"/>
+          <p:cNvSpPr txBox="1"/>
+          <p:nvPr/>
+        </p:nvSpPr>
+        <p:spPr>
+          <a:xfrm>
+            <a:off x="768096" y="4736592"/>
+            <a:ext cx="3200400" cy="1691640"/>
+          </a:xfrm>
+          <a:prstGeom prst="rect">
+            <a:avLst/>
+          </a:prstGeom>
+          <a:noFill/>
+        </p:spPr>
+        <p:txBody>
+          <a:bodyPr wrap="square" lIns="0" rIns="0" tIns="0" bIns="0">
+            <a:spAutoFit/>
+          </a:bodyPr>
+          <a:lstStyle/>
+          <a:p>
+            <a:pPr>
+              <a:lnSpc>
+                <a:spcPct val="108000"/>
+              </a:lnSpc>
+              <a:spcAft>
+                <a:spcPts val="400"/>
+              </a:spcAft>
+            </a:pPr>
+            <a:r>
+              <a:rPr sz="800">
+                <a:solidFill>
+                  <a:srgbClr val="1D1D1F"/>
+                </a:solidFill>
+                <a:latin typeface="Helvetica Neue"/>
+              </a:rPr>
+              <a:t>-  Calculated: total/average dollars billed and paid (bill_sum/mean, amt_sum/mean); overall coverage (coverage_total); raw balance change (bill_growth); spend vs. limit and a log-scaled limit (amt_over_limit, log_limit).</a:t>
+            </a:r>
+          </a:p>
+          <a:p>
+            <a:pPr>
+              <a:lnSpc>
+                <a:spcPct val="108000"/>
+              </a:lnSpc>
+              <a:spcAft>
+                <a:spcPts val="400"/>
+              </a:spcAft>
+            </a:pPr>
+            <a:r>
+              <a:rPr sz="800">
+                <a:solidFill>
+                  <a:srgbClr val="1D1D1F"/>
+                </a:solidFill>
+                <a:latin typeface="Helvetica Neue"/>
+              </a:rPr>
+              <a:t>-  Used: fed to all three models identically, same 81-feature matrix. Restores scale the ratio families strip out; trees don't need it, the GRU does.</a:t>
+            </a:r>
+          </a:p>
+        </p:txBody>
+      </p:sp>
+      <p:sp>
+        <p:nvSpPr>
+          <p:cNvPr id="22" name="Rounded Rectangle 21"/>
+          <p:cNvSpPr/>
+          <p:nvPr/>
+        </p:nvSpPr>
+        <p:spPr>
+          <a:xfrm>
+            <a:off x="7845552" y="4151376"/>
+            <a:ext cx="3456432" cy="2331720"/>
+          </a:xfrm>
+          <a:prstGeom prst="roundRect">
+            <a:avLst>
+              <a:gd name="adj" fmla="val 5000"/>
+            </a:avLst>
+          </a:prstGeom>
+          <a:solidFill>
+            <a:srgbClr val="FFFFFF"/>
+          </a:solidFill>
+          <a:ln w="12700">
+            <a:solidFill>
+              <a:srgbClr val="D2D2D7"/>
+            </a:solidFill>
+          </a:ln>
+          <a:effectLst/>
+        </p:spPr>
+        <p:style>
+          <a:lnRef idx="1">
+            <a:schemeClr val="accent1"/>
+          </a:lnRef>
+          <a:fillRef idx="3">
+            <a:schemeClr val="accent1"/>
+          </a:fillRef>
+          <a:effectRef idx="2">
+            <a:schemeClr val="accent1"/>
+          </a:effectRef>
+          <a:fontRef idx="minor">
+            <a:schemeClr val="lt1"/>
+          </a:fontRef>
+        </p:style>
+        <p:txBody>
+          <a:bodyPr rtlCol="0" anchor="ctr"/>
+          <a:lstStyle/>
+          <a:p>
+            <a:pPr algn="ctr"/>
+          </a:p>
+        </p:txBody>
+      </p:sp>
+      <p:sp>
+        <p:nvSpPr>
+          <p:cNvPr id="23" name="TextBox 22"/>
+          <p:cNvSpPr txBox="1"/>
+          <p:nvPr/>
+        </p:nvSpPr>
+        <p:spPr>
+          <a:xfrm>
+            <a:off x="7973568" y="4224528"/>
+            <a:ext cx="548640" cy="274320"/>
+          </a:xfrm>
+          <a:prstGeom prst="rect">
+            <a:avLst/>
+          </a:prstGeom>
+          <a:noFill/>
+        </p:spPr>
+        <p:txBody>
+          <a:bodyPr wrap="square" anchor="t" lIns="0" rIns="0" tIns="0" bIns="0">
+            <a:spAutoFit/>
+          </a:bodyPr>
+          <a:lstStyle/>
+          <a:p>
+            <a:pPr algn="l">
+              <a:lnSpc>
+                <a:spcPct val="100000"/>
+              </a:lnSpc>
+            </a:pPr>
+            <a:r>
+              <a:rPr sz="1600" b="1" i="0">
+                <a:solidFill>
+                  <a:srgbClr val="D2D2D7"/>
+                </a:solidFill>
+                <a:latin typeface="Helvetica Neue"/>
+              </a:rPr>
+              <a:t>06</a:t>
+            </a:r>
+          </a:p>
+        </p:txBody>
+      </p:sp>
+      <p:sp>
+        <p:nvSpPr>
+          <p:cNvPr id="24" name="TextBox 23"/>
+          <p:cNvSpPr txBox="1"/>
+          <p:nvPr/>
+        </p:nvSpPr>
+        <p:spPr>
+          <a:xfrm>
+            <a:off x="7973568" y="4462272"/>
+            <a:ext cx="3200400" cy="256032"/>
+          </a:xfrm>
+          <a:prstGeom prst="rect">
+            <a:avLst/>
+          </a:prstGeom>
+          <a:noFill/>
+        </p:spPr>
+        <p:txBody>
+          <a:bodyPr wrap="square" anchor="t" lIns="0" rIns="0" tIns="0" bIns="0">
+            <a:spAutoFit/>
+          </a:bodyPr>
+          <a:lstStyle/>
+          <a:p>
+            <a:pPr algn="l">
+              <a:lnSpc>
+                <a:spcPct val="100000"/>
+              </a:lnSpc>
+            </a:pPr>
+            <a:r>
+              <a:rPr sz="1150" b="1" i="0">
+                <a:solidFill>
+                  <a:srgbClr val="1D1D1F"/>
+                </a:solidFill>
+                <a:latin typeface="Helvetica Neue"/>
+              </a:rPr>
+              <a:t>Minimum-Payment Behaviour</a:t>
+            </a:r>
+          </a:p>
+        </p:txBody>
+      </p:sp>
+      <p:sp>
+        <p:nvSpPr>
+          <p:cNvPr id="25" name="TextBox 24"/>
+          <p:cNvSpPr txBox="1"/>
+          <p:nvPr/>
+        </p:nvSpPr>
+        <p:spPr>
+          <a:xfrm>
+            <a:off x="7973568" y="4736592"/>
+            <a:ext cx="3200400" cy="1691640"/>
+          </a:xfrm>
+          <a:prstGeom prst="rect">
+            <a:avLst/>
+          </a:prstGeom>
+          <a:noFill/>
+        </p:spPr>
+        <p:txBody>
+          <a:bodyPr wrap="square" lIns="0" rIns="0" tIns="0" bIns="0">
+            <a:spAutoFit/>
+          </a:bodyPr>
+          <a:lstStyle/>
+          <a:p>
+            <a:pPr>
+              <a:lnSpc>
+                <a:spcPct val="108000"/>
+              </a:lnSpc>
+              <a:spcAft>
+                <a:spcPts val="400"/>
+              </a:spcAft>
+            </a:pPr>
+            <a:r>
+              <a:rPr sz="800">
+                <a:solidFill>
+                  <a:srgbClr val="1D1D1F"/>
+                </a:solidFill>
+                <a:latin typeface="Helvetica Neue"/>
+              </a:rPr>
+              <a:t>-  How close payments are to the assumed 10% minimum due, on average and at worst (min_pay_ratio_mean/min).</a:t>
+            </a:r>
+          </a:p>
+          <a:p>
+            <a:pPr>
+              <a:lnSpc>
+                <a:spcPct val="108000"/>
+              </a:lnSpc>
+              <a:spcAft>
+                <a:spcPts val="400"/>
+              </a:spcAft>
+            </a:pPr>
+            <a:r>
+              <a:rPr sz="800">
+                <a:solidFill>
+                  <a:srgbClr val="1D1D1F"/>
+                </a:solidFill>
+                <a:latin typeface="Helvetica Neue"/>
+              </a:rPr>
+              <a:t>-  Months paying only around the minimum, a sign of financial strain (months_paid_about_min).</a:t>
+            </a:r>
+          </a:p>
+          <a:p>
+            <a:pPr>
+              <a:lnSpc>
+                <a:spcPct val="108000"/>
+              </a:lnSpc>
+              <a:spcAft>
+                <a:spcPts val="400"/>
+              </a:spcAft>
+            </a:pPr>
+            <a:r>
+              <a:rPr sz="800">
+                <a:solidFill>
+                  <a:srgbClr val="1D1D1F"/>
+                </a:solidFill>
+                <a:latin typeface="Helvetica Neue"/>
+              </a:rPr>
+              <a:t>-  Months paying even less than the minimum due (months_paid_under_min).</a:t>
+            </a:r>
+          </a:p>
+        </p:txBody>
+      </p:sp>
+      <p:sp>
+        <p:nvSpPr>
+          <p:cNvPr id="26" name="Rounded Rectangle 25"/>
+          <p:cNvSpPr/>
+          <p:nvPr/>
+        </p:nvSpPr>
+        <p:spPr>
+          <a:xfrm>
+            <a:off x="4242816" y="4151376"/>
+            <a:ext cx="3456432" cy="2331720"/>
+          </a:xfrm>
+          <a:prstGeom prst="roundRect">
+            <a:avLst>
+              <a:gd name="adj" fmla="val 5000"/>
+            </a:avLst>
+          </a:prstGeom>
+          <a:solidFill>
+            <a:srgbClr val="E8F2FF"/>
+          </a:solidFill>
+          <a:ln w="19050">
+            <a:solidFill>
+              <a:srgbClr val="0071E3"/>
+            </a:solidFill>
+          </a:ln>
+          <a:effectLst/>
+        </p:spPr>
+        <p:style>
+          <a:lnRef idx="1">
+            <a:schemeClr val="accent1"/>
+          </a:lnRef>
+          <a:fillRef idx="3">
+            <a:schemeClr val="accent1"/>
+          </a:fillRef>
+          <a:effectRef idx="2">
+            <a:schemeClr val="accent1"/>
+          </a:effectRef>
+          <a:fontRef idx="minor">
+            <a:schemeClr val="lt1"/>
+          </a:fontRef>
+        </p:style>
+        <p:txBody>
+          <a:bodyPr rtlCol="0" anchor="ctr"/>
+          <a:lstStyle/>
+          <a:p>
+            <a:pPr algn="ctr"/>
+          </a:p>
+        </p:txBody>
+      </p:sp>
+      <p:sp>
+        <p:nvSpPr>
+          <p:cNvPr id="27" name="TextBox 26"/>
+          <p:cNvSpPr txBox="1"/>
+          <p:nvPr/>
+        </p:nvSpPr>
+        <p:spPr>
+          <a:xfrm>
+            <a:off x="4370832" y="4224528"/>
+            <a:ext cx="548640" cy="274320"/>
+          </a:xfrm>
+          <a:prstGeom prst="rect">
+            <a:avLst/>
+          </a:prstGeom>
+          <a:noFill/>
+        </p:spPr>
+        <p:txBody>
+          <a:bodyPr wrap="square" anchor="t" lIns="0" rIns="0" tIns="0" bIns="0">
+            <a:spAutoFit/>
+          </a:bodyPr>
+          <a:lstStyle/>
+          <a:p>
+            <a:pPr algn="l">
+              <a:lnSpc>
+                <a:spcPct val="100000"/>
+              </a:lnSpc>
+            </a:pPr>
+            <a:r>
+              <a:rPr sz="1600" b="1" i="0">
+                <a:solidFill>
+                  <a:srgbClr val="D2D2D7"/>
+                </a:solidFill>
+                <a:latin typeface="Helvetica Neue"/>
+              </a:rPr>
+              <a:t>05</a:t>
+            </a:r>
+          </a:p>
+        </p:txBody>
+      </p:sp>
+      <p:sp>
+        <p:nvSpPr>
+          <p:cNvPr id="28" name="TextBox 27"/>
+          <p:cNvSpPr txBox="1"/>
+          <p:nvPr/>
+        </p:nvSpPr>
+        <p:spPr>
+          <a:xfrm>
+            <a:off x="4370832" y="4462272"/>
+            <a:ext cx="3200400" cy="256032"/>
+          </a:xfrm>
+          <a:prstGeom prst="rect">
+            <a:avLst/>
+          </a:prstGeom>
+          <a:noFill/>
+        </p:spPr>
+        <p:txBody>
+          <a:bodyPr wrap="square" anchor="t" lIns="0" rIns="0" tIns="0" bIns="0">
+            <a:spAutoFit/>
+          </a:bodyPr>
+          <a:lstStyle/>
+          <a:p>
+            <a:pPr algn="l">
+              <a:lnSpc>
+                <a:spcPct val="100000"/>
+              </a:lnSpc>
+            </a:pPr>
+            <a:r>
+              <a:rPr sz="1150" b="1" i="0">
+                <a:solidFill>
+                  <a:srgbClr val="0057B8"/>
+                </a:solidFill>
+                <a:latin typeface="Helvetica Neue"/>
+              </a:rPr>
+              <a:t>Spending Decomposition</a:t>
+            </a:r>
+          </a:p>
+        </p:txBody>
+      </p:sp>
+      <p:sp>
+        <p:nvSpPr>
+          <p:cNvPr id="29" name="TextBox 28"/>
+          <p:cNvSpPr txBox="1"/>
+          <p:nvPr/>
+        </p:nvSpPr>
+        <p:spPr>
+          <a:xfrm>
+            <a:off x="4370832" y="4736592"/>
+            <a:ext cx="3200400" cy="1691640"/>
+          </a:xfrm>
+          <a:prstGeom prst="rect">
+            <a:avLst/>
+          </a:prstGeom>
+          <a:noFill/>
+        </p:spPr>
+        <p:txBody>
+          <a:bodyPr wrap="square" lIns="0" rIns="0" tIns="0" bIns="0">
+            <a:spAutoFit/>
+          </a:bodyPr>
+          <a:lstStyle/>
+          <a:p>
+            <a:pPr>
+              <a:lnSpc>
+                <a:spcPct val="108000"/>
+              </a:lnSpc>
+              <a:spcAft>
+                <a:spcPts val="400"/>
+              </a:spcAft>
+            </a:pPr>
+            <a:r>
+              <a:rPr sz="800">
+                <a:solidFill>
+                  <a:srgbClr val="1D1D1F"/>
+                </a:solidFill>
+                <a:latin typeface="Helvetica Neue"/>
+              </a:rPr>
+              <a:t>-  spend_t = BILL_t - BILL_(t+1) + PAY_AMT_t</a:t>
+            </a:r>
+          </a:p>
+          <a:p>
+            <a:pPr>
+              <a:lnSpc>
+                <a:spcPct val="108000"/>
+              </a:lnSpc>
+              <a:spcAft>
+                <a:spcPts val="400"/>
+              </a:spcAft>
+            </a:pPr>
+            <a:r>
+              <a:rPr sz="800">
+                <a:solidFill>
+                  <a:srgbClr val="1D1D1F"/>
+                </a:solidFill>
+                <a:latin typeface="Helvetica Neue"/>
+              </a:rPr>
+              <a:t>-  Estimated dollars spent each month, plus average, peak and trend (spend1-spend5, spend_mean/max/trend).</a:t>
+            </a:r>
+          </a:p>
+          <a:p>
+            <a:pPr>
+              <a:lnSpc>
+                <a:spcPct val="108000"/>
+              </a:lnSpc>
+              <a:spcAft>
+                <a:spcPts val="400"/>
+              </a:spcAft>
+            </a:pPr>
+            <a:r>
+              <a:rPr sz="800">
+                <a:solidFill>
+                  <a:srgbClr val="1D1D1F"/>
+                </a:solidFill>
+                <a:latin typeface="Helvetica Neue"/>
+              </a:rPr>
+              <a:t>-  Months where new spending outpaced repayment (spend_minus_paid, months_spend_gt_paid).</a:t>
+            </a:r>
+          </a:p>
+          <a:p>
+            <a:pPr>
+              <a:lnSpc>
+                <a:spcPct val="108000"/>
+              </a:lnSpc>
+              <a:spcAft>
+                <a:spcPts val="400"/>
+              </a:spcAft>
+            </a:pPr>
+            <a:r>
+              <a:rPr sz="800">
+                <a:solidFill>
+                  <a:srgbClr val="1D1D1F"/>
+                </a:solidFill>
+                <a:latin typeface="Helvetica Neue"/>
+              </a:rPr>
+              <a:t>-  Separates "spent more" from "stopped paying" as the reason a balance rises.</a:t>
+            </a:r>
+          </a:p>
+          <a:p>
+            <a:pPr>
+              <a:lnSpc>
+                <a:spcPct val="108000"/>
+              </a:lnSpc>
+              <a:spcAft>
+                <a:spcPts val="400"/>
+              </a:spcAft>
+            </a:pPr>
+            <a:r>
+              <a:rPr sz="800">
+                <a:solidFill>
+                  <a:srgbClr val="1D1D1F"/>
+                </a:solidFill>
+                <a:latin typeface="Helvetica Neue"/>
+              </a:rPr>
+              <a:t>-  +0.00046 OOF / +0.00173 hidden test, the largest gain of the whole project.</a:t>
+            </a:r>
+          </a:p>
+        </p:txBody>
+      </p:sp>
+      <p:sp>
+        <p:nvSpPr>
+          <p:cNvPr id="30" name="TextBox 29"/>
+          <p:cNvSpPr txBox="1"/>
+          <p:nvPr/>
+        </p:nvSpPr>
+        <p:spPr>
+          <a:xfrm>
+            <a:off x="640080" y="6519672"/>
+            <a:ext cx="10881360" cy="274320"/>
+          </a:xfrm>
+          <a:prstGeom prst="rect">
+            <a:avLst/>
+          </a:prstGeom>
+          <a:noFill/>
+        </p:spPr>
+        <p:txBody>
+          <a:bodyPr wrap="square" anchor="t" lIns="0" rIns="0" tIns="0" bIns="0">
+            <a:spAutoFit/>
+          </a:bodyPr>
+          <a:lstStyle/>
+          <a:p>
+            <a:pPr algn="l">
+              <a:lnSpc>
+                <a:spcPct val="100000"/>
+              </a:lnSpc>
+            </a:pPr>
+            <a:r>
+              <a:rPr sz="1050" b="0" i="0">
                 <a:solidFill>
                   <a:srgbClr val="6E6E73"/>
                 </a:solidFill>
                 <a:latin typeface="Helvetica Neue"/>
               </a:rPr>
-              <a:t>Statement balances and payments are given, monthly account activity is not.</a:t>
-            </a:r>
-          </a:p>
-        </p:txBody>
-      </p:sp>
-      <p:pic>
-        <p:nvPicPr>
-          <p:cNvPr id="6" name="Picture 5" descr="spend_proxy.png"/>
-          <p:cNvPicPr>
-            <a:picLocks noChangeAspect="1"/>
-          </p:cNvPicPr>
-          <p:nvPr/>
-        </p:nvPicPr>
-        <p:blipFill>
-          <a:blip r:embed="rId2"/>
-          <a:stretch>
-            <a:fillRect/>
-          </a:stretch>
-        </p:blipFill>
-        <p:spPr>
-          <a:xfrm>
-            <a:off x="2978620" y="2286000"/>
-            <a:ext cx="6204278" cy="1737360"/>
-          </a:xfrm>
-          <a:prstGeom prst="rect">
-            <a:avLst/>
-          </a:prstGeom>
-        </p:spPr>
-      </p:pic>
-      <p:sp>
-        <p:nvSpPr>
-          <p:cNvPr id="7" name="TextBox 6"/>
-          <p:cNvSpPr txBox="1"/>
-          <p:nvPr/>
-        </p:nvSpPr>
-        <p:spPr>
-          <a:xfrm>
-            <a:off x="640080" y="4160520"/>
-            <a:ext cx="5669280" cy="822960"/>
-          </a:xfrm>
-          <a:prstGeom prst="rect">
-            <a:avLst/>
-          </a:prstGeom>
-          <a:noFill/>
-        </p:spPr>
-        <p:txBody>
-          <a:bodyPr wrap="square" anchor="t" lIns="0" rIns="0" tIns="0" bIns="0">
-            <a:spAutoFit/>
-          </a:bodyPr>
-          <a:lstStyle/>
-          <a:p>
-            <a:pPr algn="l">
-              <a:lnSpc>
-                <a:spcPct val="100000"/>
-              </a:lnSpc>
-            </a:pPr>
-            <a:r>
-              <a:rPr sz="1550" b="0" i="0">
-                <a:solidFill>
-                  <a:srgbClr val="1D1D1F"/>
-                </a:solidFill>
-                <a:latin typeface="Helvetica Neue"/>
-              </a:rPr>
-              <a:t>A rising balance from new spending is a different risk story than one from missed payments, this proxy tells them apart.</a:t>
-            </a:r>
-          </a:p>
-        </p:txBody>
-      </p:sp>
-      <p:pic>
-        <p:nvPicPr>
-          <p:cNvPr id="8" name="Picture 7" descr="feature_family_gains.png"/>
-          <p:cNvPicPr>
-            <a:picLocks noChangeAspect="1"/>
-          </p:cNvPicPr>
-          <p:nvPr/>
-        </p:nvPicPr>
-        <p:blipFill>
-          <a:blip r:embed="rId3"/>
-          <a:stretch>
-            <a:fillRect/>
-          </a:stretch>
-        </p:blipFill>
-        <p:spPr>
-          <a:xfrm>
-            <a:off x="6349238" y="3977639"/>
-            <a:ext cx="5132322" cy="2514600"/>
-          </a:xfrm>
-          <a:prstGeom prst="rect">
-            <a:avLst/>
-          </a:prstGeom>
-        </p:spPr>
-      </p:pic>
-      <p:sp>
-        <p:nvSpPr>
-          <p:cNvPr id="9" name="TextBox 8"/>
-          <p:cNvSpPr txBox="1"/>
-          <p:nvPr/>
-        </p:nvSpPr>
-        <p:spPr>
-          <a:xfrm>
-            <a:off x="640080" y="5166360"/>
-            <a:ext cx="5669280" cy="1005840"/>
-          </a:xfrm>
-          <a:prstGeom prst="rect">
-            <a:avLst/>
-          </a:prstGeom>
-          <a:noFill/>
-        </p:spPr>
-        <p:txBody>
-          <a:bodyPr wrap="square" anchor="t" lIns="0" rIns="0" tIns="0" bIns="0">
-            <a:spAutoFit/>
-          </a:bodyPr>
-          <a:lstStyle/>
-          <a:p>
-            <a:pPr algn="l">
-              <a:lnSpc>
-                <a:spcPct val="120000"/>
-              </a:lnSpc>
-            </a:pPr>
-            <a:r>
-              <a:rPr sz="1550" b="1" i="0">
-                <a:solidFill>
-                  <a:srgbClr val="0057B8"/>
-                </a:solidFill>
-                <a:latin typeface="Helvetica Neue"/>
-              </a:rPr>
-              <a:t>+0.00046 OOF log loss  ·  +0.00173 hidden-test log loss.</a:t>
-            </a:r>
-          </a:p>
-          <a:p>
-            <a:pPr algn="l">
-              <a:lnSpc>
-                <a:spcPct val="120000"/>
-              </a:lnSpc>
-            </a:pPr>
-            <a:r>
-              <a:rPr sz="1550" b="1" i="0">
-                <a:solidFill>
-                  <a:srgbClr val="0057B8"/>
-                </a:solidFill>
-                <a:latin typeface="Helvetica Neue"/>
-              </a:rPr>
-              <a:t>Six other feature families never cleared the 0.0005 noise threshold.</a:t>
-            </a:r>
-          </a:p>
-        </p:txBody>
-      </p:sp>
-      <p:sp>
-        <p:nvSpPr>
-          <p:cNvPr id="10" name="TextBox 9"/>
+              <a:t>Six additional feature families were tried and rejected (behavioural signatures, spend-as-sequence, interaction terms, peer-relative limit, velocity/acceleration, target encoding); none cleared the 0.0005 noise threshold.</a:t>
+            </a:r>
+          </a:p>
+        </p:txBody>
+      </p:sp>
+      <p:sp>
+        <p:nvSpPr>
+          <p:cNvPr id="31" name="TextBox 30"/>
           <p:cNvSpPr txBox="1"/>
           <p:nvPr/>
         </p:nvSpPr>

</xml_diff>